<commit_message>
Fix header logo rendering: replace uninstalled icon-font glyphs with transparent PNG extracted from original PDF
The redrob and H2S logos use a custom icon font not installed on this machine
and not embedded in the PPTX. Extracted vector-correct glyphs from original
PDF using PyMuPDF, applied brightness-threshold alpha to blend with dark
header bar, and inserted as picture shapes over the hidden garbled text boxes.
Also moved Slide 7 stats callout above the output box to remove overlap.

Co-Authored-By: Claude Sonnet 4.6 <noreply@anthropic.com>
</commit_message>
<xml_diff>
--- a/HackerX_Methodology.pptx
+++ b/HackerX_Methodology.pptx
@@ -1577,7 +1577,7 @@
         </p:nvSpPr>
         <p:spPr>
           <a:xfrm>
-            <a:off x="277742" y="1171447"/>
+            <a:off x="-5486400" y="1171447"/>
             <a:ext cx="835660" cy="254000"/>
           </a:xfrm>
           <a:prstGeom prst="rect">
@@ -1643,7 +1643,7 @@
         </p:nvSpPr>
         <p:spPr>
           <a:xfrm>
-            <a:off x="1380056" y="1171447"/>
+            <a:off x="-5486400" y="1171447"/>
             <a:ext cx="371475" cy="254000"/>
           </a:xfrm>
           <a:prstGeom prst="rect">
@@ -2054,6 +2054,30 @@
           </a:p>
         </p:txBody>
       </p:sp>
+      <p:pic>
+        <p:nvPicPr>
+          <p:cNvPr id="6" name="Picture 5" descr="logos_transparent.png"/>
+          <p:cNvPicPr>
+            <a:picLocks noChangeAspect="1"/>
+          </p:cNvPicPr>
+          <p:nvPr/>
+        </p:nvPicPr>
+        <p:blipFill>
+          <a:blip r:embed="rId3"/>
+          <a:stretch>
+            <a:fillRect/>
+          </a:stretch>
+        </p:blipFill>
+        <p:spPr>
+          <a:xfrm>
+            <a:off x="256032" y="1060704"/>
+            <a:ext cx="1816377" cy="512064"/>
+          </a:xfrm>
+          <a:prstGeom prst="rect">
+            <a:avLst/>
+          </a:prstGeom>
+        </p:spPr>
+      </p:pic>
     </p:spTree>
   </p:cSld>
   <p:clrMapOvr>
@@ -2087,7 +2111,7 @@
         </p:nvSpPr>
         <p:spPr>
           <a:xfrm>
-            <a:off x="4156431" y="2016871"/>
+            <a:off x="-5486400" y="2016871"/>
             <a:ext cx="922019" cy="387350"/>
           </a:xfrm>
           <a:prstGeom prst="rect">
@@ -2137,7 +2161,7 @@
         </p:nvSpPr>
         <p:spPr>
           <a:xfrm>
-            <a:off x="5518076" y="2016871"/>
+            <a:off x="-5486400" y="2016871"/>
             <a:ext cx="642620" cy="387350"/>
           </a:xfrm>
           <a:prstGeom prst="rect"/>
@@ -2184,6 +2208,30 @@
           </a:p>
         </p:txBody>
       </p:sp>
+      <p:pic>
+        <p:nvPicPr>
+          <p:cNvPr id="4" name="Picture 3" descr="logos_s11.png"/>
+          <p:cNvPicPr>
+            <a:picLocks noChangeAspect="1"/>
+          </p:cNvPicPr>
+          <p:nvPr/>
+        </p:nvPicPr>
+        <p:blipFill>
+          <a:blip r:embed="rId2"/>
+          <a:stretch>
+            <a:fillRect/>
+          </a:stretch>
+        </p:blipFill>
+        <p:spPr>
+          <a:xfrm>
+            <a:off x="3074862" y="2020824"/>
+            <a:ext cx="3908675" cy="384048"/>
+          </a:xfrm>
+          <a:prstGeom prst="rect">
+            <a:avLst/>
+          </a:prstGeom>
+        </p:spPr>
+      </p:pic>
     </p:spTree>
   </p:cSld>
   <p:clrMapOvr>
@@ -2217,7 +2265,7 @@
         </p:nvSpPr>
         <p:spPr>
           <a:xfrm>
-            <a:off x="277742" y="1171447"/>
+            <a:off x="-5486400" y="1171447"/>
             <a:ext cx="835660" cy="254000"/>
           </a:xfrm>
           <a:prstGeom prst="rect">
@@ -2283,7 +2331,7 @@
         </p:nvSpPr>
         <p:spPr>
           <a:xfrm>
-            <a:off x="1380056" y="1171447"/>
+            <a:off x="-5486400" y="1171447"/>
             <a:ext cx="371475" cy="254000"/>
           </a:xfrm>
           <a:prstGeom prst="rect">
@@ -2595,6 +2643,30 @@
           </a:p>
         </p:txBody>
       </p:sp>
+      <p:pic>
+        <p:nvPicPr>
+          <p:cNvPr id="6" name="Picture 5" descr="logos_transparent.png"/>
+          <p:cNvPicPr>
+            <a:picLocks noChangeAspect="1"/>
+          </p:cNvPicPr>
+          <p:nvPr/>
+        </p:nvPicPr>
+        <p:blipFill>
+          <a:blip r:embed="rId3"/>
+          <a:stretch>
+            <a:fillRect/>
+          </a:stretch>
+        </p:blipFill>
+        <p:spPr>
+          <a:xfrm>
+            <a:off x="256032" y="1060704"/>
+            <a:ext cx="1816377" cy="512064"/>
+          </a:xfrm>
+          <a:prstGeom prst="rect">
+            <a:avLst/>
+          </a:prstGeom>
+        </p:spPr>
+      </p:pic>
     </p:spTree>
   </p:cSld>
   <p:clrMapOvr>
@@ -3499,7 +3571,7 @@
         </p:nvSpPr>
         <p:spPr>
           <a:xfrm>
-            <a:off x="277742" y="1171447"/>
+            <a:off x="-5486400" y="1171447"/>
             <a:ext cx="835660" cy="254000"/>
           </a:xfrm>
           <a:prstGeom prst="rect">
@@ -3565,7 +3637,7 @@
         </p:nvSpPr>
         <p:spPr>
           <a:xfrm>
-            <a:off x="1380056" y="1171447"/>
+            <a:off x="-5486400" y="1171447"/>
             <a:ext cx="371475" cy="254000"/>
           </a:xfrm>
           <a:prstGeom prst="rect">
@@ -4441,6 +4513,30 @@
           </a:p>
         </p:txBody>
       </p:sp>
+      <p:pic>
+        <p:nvPicPr>
+          <p:cNvPr id="21" name="Picture 20" descr="logos_transparent.png"/>
+          <p:cNvPicPr>
+            <a:picLocks noChangeAspect="1"/>
+          </p:cNvPicPr>
+          <p:nvPr/>
+        </p:nvPicPr>
+        <p:blipFill>
+          <a:blip r:embed="rId3"/>
+          <a:stretch>
+            <a:fillRect/>
+          </a:stretch>
+        </p:blipFill>
+        <p:spPr>
+          <a:xfrm>
+            <a:off x="256032" y="1060704"/>
+            <a:ext cx="1816377" cy="512064"/>
+          </a:xfrm>
+          <a:prstGeom prst="rect">
+            <a:avLst/>
+          </a:prstGeom>
+        </p:spPr>
+      </p:pic>
     </p:spTree>
   </p:cSld>
   <p:clrMapOvr>
@@ -4544,7 +4640,7 @@
         </p:nvSpPr>
         <p:spPr>
           <a:xfrm>
-            <a:off x="277742" y="1171447"/>
+            <a:off x="-5486400" y="1171447"/>
             <a:ext cx="835660" cy="254000"/>
           </a:xfrm>
           <a:prstGeom prst="rect">
@@ -4610,7 +4706,7 @@
         </p:nvSpPr>
         <p:spPr>
           <a:xfrm>
-            <a:off x="1380056" y="1171447"/>
+            <a:off x="-5486400" y="1171447"/>
             <a:ext cx="371475" cy="254000"/>
           </a:xfrm>
           <a:prstGeom prst="rect">
@@ -5561,8 +5657,8 @@
         </p:nvSpPr>
         <p:spPr>
           <a:xfrm>
-            <a:off x="365760" y="6053327"/>
-            <a:ext cx="3200400" cy="329184"/>
+            <a:off x="320040" y="5623560"/>
+            <a:ext cx="3200400" cy="365760"/>
           </a:xfrm>
           <a:prstGeom prst="rect">
             <a:avLst/>
@@ -5587,6 +5683,30 @@
           </a:p>
         </p:txBody>
       </p:sp>
+      <p:pic>
+        <p:nvPicPr>
+          <p:cNvPr id="28" name="Picture 27" descr="logos_transparent.png"/>
+          <p:cNvPicPr>
+            <a:picLocks noChangeAspect="1"/>
+          </p:cNvPicPr>
+          <p:nvPr/>
+        </p:nvPicPr>
+        <p:blipFill>
+          <a:blip r:embed="rId4"/>
+          <a:stretch>
+            <a:fillRect/>
+          </a:stretch>
+        </p:blipFill>
+        <p:spPr>
+          <a:xfrm>
+            <a:off x="256032" y="1060704"/>
+            <a:ext cx="1816377" cy="512064"/>
+          </a:xfrm>
+          <a:prstGeom prst="rect">
+            <a:avLst/>
+          </a:prstGeom>
+        </p:spPr>
+      </p:pic>
     </p:spTree>
   </p:cSld>
   <p:clrMapOvr>
@@ -5668,7 +5788,7 @@
         </p:nvSpPr>
         <p:spPr>
           <a:xfrm>
-            <a:off x="277742" y="1171447"/>
+            <a:off x="-5486400" y="1171447"/>
             <a:ext cx="835660" cy="254000"/>
           </a:xfrm>
           <a:prstGeom prst="rect">
@@ -5734,7 +5854,7 @@
         </p:nvSpPr>
         <p:spPr>
           <a:xfrm>
-            <a:off x="1380056" y="1171447"/>
+            <a:off x="-5486400" y="1171447"/>
             <a:ext cx="371475" cy="254000"/>
           </a:xfrm>
           <a:prstGeom prst="rect">
@@ -6124,6 +6244,30 @@
           </a:p>
         </p:txBody>
       </p:sp>
+      <p:pic>
+        <p:nvPicPr>
+          <p:cNvPr id="7" name="Picture 6" descr="logos_transparent.png"/>
+          <p:cNvPicPr>
+            <a:picLocks noChangeAspect="1"/>
+          </p:cNvPicPr>
+          <p:nvPr/>
+        </p:nvPicPr>
+        <p:blipFill>
+          <a:blip r:embed="rId3"/>
+          <a:stretch>
+            <a:fillRect/>
+          </a:stretch>
+        </p:blipFill>
+        <p:spPr>
+          <a:xfrm>
+            <a:off x="256032" y="1060704"/>
+            <a:ext cx="1816377" cy="512064"/>
+          </a:xfrm>
+          <a:prstGeom prst="rect">
+            <a:avLst/>
+          </a:prstGeom>
+        </p:spPr>
+      </p:pic>
     </p:spTree>
   </p:cSld>
   <p:clrMapOvr>
@@ -6227,7 +6371,7 @@
         </p:nvSpPr>
         <p:spPr>
           <a:xfrm>
-            <a:off x="277742" y="1171447"/>
+            <a:off x="-5486400" y="1171447"/>
             <a:ext cx="835660" cy="254000"/>
           </a:xfrm>
           <a:prstGeom prst="rect">
@@ -6293,7 +6437,7 @@
         </p:nvSpPr>
         <p:spPr>
           <a:xfrm>
-            <a:off x="1380056" y="1171447"/>
+            <a:off x="-5486400" y="1171447"/>
             <a:ext cx="371475" cy="254000"/>
           </a:xfrm>
           <a:prstGeom prst="rect">
@@ -6584,6 +6728,30 @@
           </a:p>
         </p:txBody>
       </p:sp>
+      <p:pic>
+        <p:nvPicPr>
+          <p:cNvPr id="8" name="Picture 7" descr="logos_transparent.png"/>
+          <p:cNvPicPr>
+            <a:picLocks noChangeAspect="1"/>
+          </p:cNvPicPr>
+          <p:nvPr/>
+        </p:nvPicPr>
+        <p:blipFill>
+          <a:blip r:embed="rId4"/>
+          <a:stretch>
+            <a:fillRect/>
+          </a:stretch>
+        </p:blipFill>
+        <p:spPr>
+          <a:xfrm>
+            <a:off x="256032" y="1060704"/>
+            <a:ext cx="1816377" cy="512064"/>
+          </a:xfrm>
+          <a:prstGeom prst="rect">
+            <a:avLst/>
+          </a:prstGeom>
+        </p:spPr>
+      </p:pic>
     </p:spTree>
   </p:cSld>
   <p:clrMapOvr>

</xml_diff>

<commit_message>
Fix logo z-order and slide content visibility on slides 3-5
image8.png was appended last in the spTree by restore_bg.py, rendering
it on top of all text content and blanking slides 3, 4, 5. Moved it
to spTree index 2 (send-to-back) so content shapes render above it.
PDF regenerated from corrected deck.

Co-Authored-By: Claude Sonnet 4.6 <noreply@anthropic.com>
</commit_message>
<xml_diff>
--- a/HackerX_Methodology.pptx
+++ b/HackerX_Methodology.pptx
@@ -5,17 +5,17 @@
     <p:sldMasterId id="2147483648" r:id="rId1"/>
   </p:sldMasterIdLst>
   <p:sldIdLst>
-    <p:sldId id="256" r:id="rId6"/>
-    <p:sldId id="257" r:id="rId7"/>
-    <p:sldId id="258" r:id="rId8"/>
-    <p:sldId id="259" r:id="rId9"/>
-    <p:sldId id="260" r:id="rId10"/>
-    <p:sldId id="261" r:id="rId11"/>
-    <p:sldId id="262" r:id="rId12"/>
-    <p:sldId id="263" r:id="rId13"/>
-    <p:sldId id="264" r:id="rId14"/>
-    <p:sldId id="265" r:id="rId15"/>
-    <p:sldId id="266" r:id="rId16"/>
+    <p:sldId id="256" r:id="rId2"/>
+    <p:sldId id="257" r:id="rId3"/>
+    <p:sldId id="258" r:id="rId4"/>
+    <p:sldId id="259" r:id="rId5"/>
+    <p:sldId id="260" r:id="rId6"/>
+    <p:sldId id="261" r:id="rId7"/>
+    <p:sldId id="262" r:id="rId8"/>
+    <p:sldId id="263" r:id="rId9"/>
+    <p:sldId id="264" r:id="rId10"/>
+    <p:sldId id="265" r:id="rId11"/>
+    <p:sldId id="266" r:id="rId12"/>
   </p:sldIdLst>
   <p:sldSz cx="10058400" cy="7772400"/>
   <p:notesSz cx="10058400" cy="7772400"/>
@@ -24,11 +24,27 @@
       <a:defRPr kern="0"/>
     </a:defPPr>
   </p:defaultTextStyle>
+  <p:extLst>
+    <p:ext uri="{EFAFB233-063F-42B5-8137-9DF3F51BA10A}">
+      <p15:sldGuideLst xmlns:p15="http://schemas.microsoft.com/office/powerpoint/2012/main">
+        <p15:guide id="1" orient="horz" pos="2880">
+          <p15:clr>
+            <a:srgbClr val="A4A3A4"/>
+          </p15:clr>
+        </p15:guide>
+        <p15:guide id="2" pos="2160">
+          <p15:clr>
+            <a:srgbClr val="A4A3A4"/>
+          </p15:clr>
+        </p15:guide>
+      </p15:sldGuideLst>
+    </p:ext>
+  </p:extLst>
 </p:presentation>
 </file>
 
 <file path=ppt/slideLayouts/slideLayout1.xml><?xml version="1.0" encoding="utf-8"?>
-<p:sldLayout xmlns:a="http://schemas.openxmlformats.org/drawingml/2006/main" xmlns:r="http://schemas.openxmlformats.org/officeDocument/2006/relationships" xmlns:p="http://schemas.openxmlformats.org/presentationml/2006/main" preserve="1" type="obj">
+<p:sldLayout xmlns:a="http://schemas.openxmlformats.org/drawingml/2006/main" xmlns:r="http://schemas.openxmlformats.org/officeDocument/2006/relationships" xmlns:p="http://schemas.openxmlformats.org/presentationml/2006/main" type="obj" preserve="1">
   <p:cSld name="Title Slide">
     <p:spTree>
       <p:nvGrpSpPr>
@@ -78,7 +94,9 @@
               </a:defRPr>
             </a:lvl1pPr>
           </a:lstStyle>
-          <a:p/>
+          <a:p>
+            <a:endParaRPr/>
+          </a:p>
         </p:txBody>
       </p:sp>
       <p:sp>
@@ -109,7 +127,9 @@
               <a:defRPr/>
             </a:lvl1pPr>
           </a:lstStyle>
-          <a:p/>
+          <a:p>
+            <a:endParaRPr/>
+          </a:p>
         </p:txBody>
       </p:sp>
       <p:sp>
@@ -119,7 +139,7 @@
             <a:spLocks noGrp="1"/>
           </p:cNvSpPr>
           <p:nvPr>
-            <p:ph type="ftr" idx="5" sz="quarter"/>
+            <p:ph type="ftr" sz="quarter" idx="5"/>
           </p:nvPr>
         </p:nvSpPr>
         <p:spPr/>
@@ -136,7 +156,9 @@
               </a:defRPr>
             </a:lvl1pPr>
           </a:lstStyle>
-          <a:p/>
+          <a:p>
+            <a:endParaRPr/>
+          </a:p>
         </p:txBody>
       </p:sp>
       <p:sp>
@@ -146,7 +168,7 @@
             <a:spLocks noGrp="1"/>
           </p:cNvSpPr>
           <p:nvPr>
-            <p:ph type="dt" idx="6" sz="half"/>
+            <p:ph type="dt" sz="half" idx="6"/>
           </p:nvPr>
         </p:nvSpPr>
         <p:spPr/>
@@ -166,7 +188,9 @@
           <a:p>
             <a:fld id="{1D8BD707-D9CF-40AE-B4C6-C98DA3205C09}" type="datetimeFigureOut">
               <a:rPr lang="en-US"/>
+              <a:t>6/29/2026</a:t>
             </a:fld>
+            <a:endParaRPr lang="en-US"/>
           </a:p>
         </p:txBody>
       </p:sp>
@@ -177,7 +201,7 @@
             <a:spLocks noGrp="1"/>
           </p:cNvSpPr>
           <p:nvPr>
-            <p:ph type="sldNum" idx="7" sz="quarter"/>
+            <p:ph type="sldNum" sz="quarter" idx="7"/>
           </p:nvPr>
         </p:nvSpPr>
         <p:spPr/>
@@ -196,8 +220,9 @@
           </a:lstStyle>
           <a:p>
             <a:fld id="{B6F15528-21DE-4FAA-801E-634DDDAF4B2B}" type="slidenum">
-              <a:t>#</a:t>
+              <a:t>‹#›</a:t>
             </a:fld>
+            <a:endParaRPr/>
           </a:p>
         </p:txBody>
       </p:sp>
@@ -210,7 +235,7 @@
 </file>
 
 <file path=ppt/slideLayouts/slideLayout2.xml><?xml version="1.0" encoding="utf-8"?>
-<p:sldLayout xmlns:a="http://schemas.openxmlformats.org/drawingml/2006/main" xmlns:r="http://schemas.openxmlformats.org/officeDocument/2006/relationships" xmlns:p="http://schemas.openxmlformats.org/presentationml/2006/main" preserve="1" type="obj" showMasterSp="0">
+<p:sldLayout xmlns:a="http://schemas.openxmlformats.org/drawingml/2006/main" xmlns:r="http://schemas.openxmlformats.org/officeDocument/2006/relationships" xmlns:p="http://schemas.openxmlformats.org/presentationml/2006/main" showMasterSp="0" type="obj" preserve="1">
   <p:cSld name="Title and Content">
     <p:bg>
       <p:bgPr>
@@ -301,7 +326,9 @@
         <p:txBody>
           <a:bodyPr wrap="square" lIns="0" tIns="0" rIns="0" bIns="0" rtlCol="0"/>
           <a:lstStyle/>
-          <a:p/>
+          <a:p>
+            <a:endParaRPr/>
+          </a:p>
         </p:txBody>
       </p:sp>
       <p:sp>
@@ -328,7 +355,9 @@
               </a:defRPr>
             </a:lvl1pPr>
           </a:lstStyle>
-          <a:p/>
+          <a:p>
+            <a:endParaRPr/>
+          </a:p>
         </p:txBody>
       </p:sp>
       <p:sp>
@@ -349,7 +378,9 @@
               <a:defRPr/>
             </a:lvl1pPr>
           </a:lstStyle>
-          <a:p/>
+          <a:p>
+            <a:endParaRPr/>
+          </a:p>
         </p:txBody>
       </p:sp>
       <p:sp>
@@ -359,7 +390,7 @@
             <a:spLocks noGrp="1"/>
           </p:cNvSpPr>
           <p:nvPr>
-            <p:ph type="ftr" idx="5" sz="quarter"/>
+            <p:ph type="ftr" sz="quarter" idx="5"/>
           </p:nvPr>
         </p:nvSpPr>
         <p:spPr/>
@@ -376,7 +407,9 @@
               </a:defRPr>
             </a:lvl1pPr>
           </a:lstStyle>
-          <a:p/>
+          <a:p>
+            <a:endParaRPr/>
+          </a:p>
         </p:txBody>
       </p:sp>
       <p:sp>
@@ -386,7 +419,7 @@
             <a:spLocks noGrp="1"/>
           </p:cNvSpPr>
           <p:nvPr>
-            <p:ph type="dt" idx="6" sz="half"/>
+            <p:ph type="dt" sz="half" idx="6"/>
           </p:nvPr>
         </p:nvSpPr>
         <p:spPr/>
@@ -406,7 +439,9 @@
           <a:p>
             <a:fld id="{1D8BD707-D9CF-40AE-B4C6-C98DA3205C09}" type="datetimeFigureOut">
               <a:rPr lang="en-US"/>
+              <a:t>6/29/2026</a:t>
             </a:fld>
+            <a:endParaRPr lang="en-US"/>
           </a:p>
         </p:txBody>
       </p:sp>
@@ -417,7 +452,7 @@
             <a:spLocks noGrp="1"/>
           </p:cNvSpPr>
           <p:nvPr>
-            <p:ph type="sldNum" idx="7" sz="quarter"/>
+            <p:ph type="sldNum" sz="quarter" idx="7"/>
           </p:nvPr>
         </p:nvSpPr>
         <p:spPr/>
@@ -436,8 +471,9 @@
           </a:lstStyle>
           <a:p>
             <a:fld id="{B6F15528-21DE-4FAA-801E-634DDDAF4B2B}" type="slidenum">
-              <a:t>#</a:t>
+              <a:t>‹#›</a:t>
             </a:fld>
+            <a:endParaRPr/>
           </a:p>
         </p:txBody>
       </p:sp>
@@ -450,7 +486,7 @@
 </file>
 
 <file path=ppt/slideLayouts/slideLayout3.xml><?xml version="1.0" encoding="utf-8"?>
-<p:sldLayout xmlns:a="http://schemas.openxmlformats.org/drawingml/2006/main" xmlns:r="http://schemas.openxmlformats.org/officeDocument/2006/relationships" xmlns:p="http://schemas.openxmlformats.org/presentationml/2006/main" preserve="1" type="obj">
+<p:sldLayout xmlns:a="http://schemas.openxmlformats.org/drawingml/2006/main" xmlns:r="http://schemas.openxmlformats.org/officeDocument/2006/relationships" xmlns:p="http://schemas.openxmlformats.org/presentationml/2006/main" type="obj" preserve="1">
   <p:cSld name="Two Content">
     <p:spTree>
       <p:nvGrpSpPr>
@@ -490,7 +526,9 @@
               </a:defRPr>
             </a:lvl1pPr>
           </a:lstStyle>
-          <a:p/>
+          <a:p>
+            <a:endParaRPr/>
+          </a:p>
         </p:txBody>
       </p:sp>
       <p:sp>
@@ -500,7 +538,7 @@
             <a:spLocks noGrp="1"/>
           </p:cNvSpPr>
           <p:nvPr>
-            <p:ph idx="2" sz="half"/>
+            <p:ph sz="half" idx="2"/>
           </p:nvPr>
         </p:nvSpPr>
         <p:spPr>
@@ -521,7 +559,9 @@
               <a:defRPr/>
             </a:lvl1pPr>
           </a:lstStyle>
-          <a:p/>
+          <a:p>
+            <a:endParaRPr/>
+          </a:p>
         </p:txBody>
       </p:sp>
       <p:sp>
@@ -531,7 +571,7 @@
             <a:spLocks noGrp="1"/>
           </p:cNvSpPr>
           <p:nvPr>
-            <p:ph idx="3" sz="half"/>
+            <p:ph sz="half" idx="3"/>
           </p:nvPr>
         </p:nvSpPr>
         <p:spPr>
@@ -552,7 +592,9 @@
               <a:defRPr/>
             </a:lvl1pPr>
           </a:lstStyle>
-          <a:p/>
+          <a:p>
+            <a:endParaRPr/>
+          </a:p>
         </p:txBody>
       </p:sp>
       <p:sp>
@@ -562,7 +604,7 @@
             <a:spLocks noGrp="1"/>
           </p:cNvSpPr>
           <p:nvPr>
-            <p:ph type="ftr" idx="5" sz="quarter"/>
+            <p:ph type="ftr" sz="quarter" idx="5"/>
           </p:nvPr>
         </p:nvSpPr>
         <p:spPr/>
@@ -579,7 +621,9 @@
               </a:defRPr>
             </a:lvl1pPr>
           </a:lstStyle>
-          <a:p/>
+          <a:p>
+            <a:endParaRPr/>
+          </a:p>
         </p:txBody>
       </p:sp>
       <p:sp>
@@ -589,7 +633,7 @@
             <a:spLocks noGrp="1"/>
           </p:cNvSpPr>
           <p:nvPr>
-            <p:ph type="dt" idx="6" sz="half"/>
+            <p:ph type="dt" sz="half" idx="6"/>
           </p:nvPr>
         </p:nvSpPr>
         <p:spPr/>
@@ -609,7 +653,9 @@
           <a:p>
             <a:fld id="{1D8BD707-D9CF-40AE-B4C6-C98DA3205C09}" type="datetimeFigureOut">
               <a:rPr lang="en-US"/>
+              <a:t>6/29/2026</a:t>
             </a:fld>
+            <a:endParaRPr lang="en-US"/>
           </a:p>
         </p:txBody>
       </p:sp>
@@ -620,7 +666,7 @@
             <a:spLocks noGrp="1"/>
           </p:cNvSpPr>
           <p:nvPr>
-            <p:ph type="sldNum" idx="7" sz="quarter"/>
+            <p:ph type="sldNum" sz="quarter" idx="7"/>
           </p:nvPr>
         </p:nvSpPr>
         <p:spPr/>
@@ -639,8 +685,9 @@
           </a:lstStyle>
           <a:p>
             <a:fld id="{B6F15528-21DE-4FAA-801E-634DDDAF4B2B}" type="slidenum">
-              <a:t>#</a:t>
+              <a:t>‹#›</a:t>
             </a:fld>
+            <a:endParaRPr/>
           </a:p>
         </p:txBody>
       </p:sp>
@@ -653,7 +700,7 @@
 </file>
 
 <file path=ppt/slideLayouts/slideLayout4.xml><?xml version="1.0" encoding="utf-8"?>
-<p:sldLayout xmlns:a="http://schemas.openxmlformats.org/drawingml/2006/main" xmlns:r="http://schemas.openxmlformats.org/officeDocument/2006/relationships" xmlns:p="http://schemas.openxmlformats.org/presentationml/2006/main" preserve="1" type="obj" showMasterSp="0">
+<p:sldLayout xmlns:a="http://schemas.openxmlformats.org/drawingml/2006/main" xmlns:r="http://schemas.openxmlformats.org/officeDocument/2006/relationships" xmlns:p="http://schemas.openxmlformats.org/presentationml/2006/main" showMasterSp="0" type="obj" preserve="1">
   <p:cSld name="Title Only">
     <p:bg>
       <p:bgPr>
@@ -788,7 +835,9 @@
         <p:txBody>
           <a:bodyPr wrap="square" lIns="0" tIns="0" rIns="0" bIns="0" rtlCol="0"/>
           <a:lstStyle/>
-          <a:p/>
+          <a:p>
+            <a:endParaRPr/>
+          </a:p>
         </p:txBody>
       </p:sp>
       <p:sp>
@@ -815,7 +864,9 @@
               </a:defRPr>
             </a:lvl1pPr>
           </a:lstStyle>
-          <a:p/>
+          <a:p>
+            <a:endParaRPr/>
+          </a:p>
         </p:txBody>
       </p:sp>
       <p:sp>
@@ -825,7 +876,7 @@
             <a:spLocks noGrp="1"/>
           </p:cNvSpPr>
           <p:nvPr>
-            <p:ph type="ftr" idx="5" sz="quarter"/>
+            <p:ph type="ftr" sz="quarter" idx="5"/>
           </p:nvPr>
         </p:nvSpPr>
         <p:spPr/>
@@ -842,7 +893,9 @@
               </a:defRPr>
             </a:lvl1pPr>
           </a:lstStyle>
-          <a:p/>
+          <a:p>
+            <a:endParaRPr/>
+          </a:p>
         </p:txBody>
       </p:sp>
       <p:sp>
@@ -852,7 +905,7 @@
             <a:spLocks noGrp="1"/>
           </p:cNvSpPr>
           <p:nvPr>
-            <p:ph type="dt" idx="6" sz="half"/>
+            <p:ph type="dt" sz="half" idx="6"/>
           </p:nvPr>
         </p:nvSpPr>
         <p:spPr/>
@@ -872,7 +925,9 @@
           <a:p>
             <a:fld id="{1D8BD707-D9CF-40AE-B4C6-C98DA3205C09}" type="datetimeFigureOut">
               <a:rPr lang="en-US"/>
+              <a:t>6/29/2026</a:t>
             </a:fld>
+            <a:endParaRPr lang="en-US"/>
           </a:p>
         </p:txBody>
       </p:sp>
@@ -883,7 +938,7 @@
             <a:spLocks noGrp="1"/>
           </p:cNvSpPr>
           <p:nvPr>
-            <p:ph type="sldNum" idx="7" sz="quarter"/>
+            <p:ph type="sldNum" sz="quarter" idx="7"/>
           </p:nvPr>
         </p:nvSpPr>
         <p:spPr/>
@@ -902,8 +957,9 @@
           </a:lstStyle>
           <a:p>
             <a:fld id="{B6F15528-21DE-4FAA-801E-634DDDAF4B2B}" type="slidenum">
-              <a:t>#</a:t>
+              <a:t>‹#›</a:t>
             </a:fld>
+            <a:endParaRPr/>
           </a:p>
         </p:txBody>
       </p:sp>
@@ -916,7 +972,7 @@
 </file>
 
 <file path=ppt/slideLayouts/slideLayout5.xml><?xml version="1.0" encoding="utf-8"?>
-<p:sldLayout xmlns:a="http://schemas.openxmlformats.org/drawingml/2006/main" xmlns:r="http://schemas.openxmlformats.org/officeDocument/2006/relationships" xmlns:p="http://schemas.openxmlformats.org/presentationml/2006/main" preserve="1" type="obj">
+<p:sldLayout xmlns:a="http://schemas.openxmlformats.org/drawingml/2006/main" xmlns:r="http://schemas.openxmlformats.org/officeDocument/2006/relationships" xmlns:p="http://schemas.openxmlformats.org/presentationml/2006/main" type="obj" preserve="1">
   <p:cSld name="Blank">
     <p:spTree>
       <p:nvGrpSpPr>
@@ -939,7 +995,7 @@
             <a:spLocks noGrp="1"/>
           </p:cNvSpPr>
           <p:nvPr>
-            <p:ph type="ftr" idx="5" sz="quarter"/>
+            <p:ph type="ftr" sz="quarter" idx="5"/>
           </p:nvPr>
         </p:nvSpPr>
         <p:spPr/>
@@ -956,7 +1012,9 @@
               </a:defRPr>
             </a:lvl1pPr>
           </a:lstStyle>
-          <a:p/>
+          <a:p>
+            <a:endParaRPr/>
+          </a:p>
         </p:txBody>
       </p:sp>
       <p:sp>
@@ -966,7 +1024,7 @@
             <a:spLocks noGrp="1"/>
           </p:cNvSpPr>
           <p:nvPr>
-            <p:ph type="dt" idx="6" sz="half"/>
+            <p:ph type="dt" sz="half" idx="6"/>
           </p:nvPr>
         </p:nvSpPr>
         <p:spPr/>
@@ -986,7 +1044,9 @@
           <a:p>
             <a:fld id="{1D8BD707-D9CF-40AE-B4C6-C98DA3205C09}" type="datetimeFigureOut">
               <a:rPr lang="en-US"/>
+              <a:t>6/29/2026</a:t>
             </a:fld>
+            <a:endParaRPr lang="en-US"/>
           </a:p>
         </p:txBody>
       </p:sp>
@@ -997,7 +1057,7 @@
             <a:spLocks noGrp="1"/>
           </p:cNvSpPr>
           <p:nvPr>
-            <p:ph type="sldNum" idx="7" sz="quarter"/>
+            <p:ph type="sldNum" sz="quarter" idx="7"/>
           </p:nvPr>
         </p:nvSpPr>
         <p:spPr/>
@@ -1016,8 +1076,9 @@
           </a:lstStyle>
           <a:p>
             <a:fld id="{B6F15528-21DE-4FAA-801E-634DDDAF4B2B}" type="slidenum">
-              <a:t>#</a:t>
+              <a:t>‹#›</a:t>
             </a:fld>
+            <a:endParaRPr/>
           </a:p>
         </p:txBody>
       </p:sp>
@@ -1110,7 +1171,9 @@
               </a:defRPr>
             </a:lvl1pPr>
           </a:lstStyle>
-          <a:p/>
+          <a:p>
+            <a:endParaRPr/>
+          </a:p>
         </p:txBody>
       </p:sp>
       <p:sp>
@@ -1141,7 +1204,9 @@
               <a:defRPr/>
             </a:lvl1pPr>
           </a:lstStyle>
-          <a:p/>
+          <a:p>
+            <a:endParaRPr/>
+          </a:p>
         </p:txBody>
       </p:sp>
       <p:sp>
@@ -1151,7 +1216,7 @@
             <a:spLocks noGrp="1"/>
           </p:cNvSpPr>
           <p:nvPr>
-            <p:ph type="ftr" idx="5" sz="quarter"/>
+            <p:ph type="ftr" sz="quarter" idx="5"/>
           </p:nvPr>
         </p:nvSpPr>
         <p:spPr>
@@ -1178,7 +1243,9 @@
               </a:defRPr>
             </a:lvl1pPr>
           </a:lstStyle>
-          <a:p/>
+          <a:p>
+            <a:endParaRPr/>
+          </a:p>
         </p:txBody>
       </p:sp>
       <p:sp>
@@ -1188,7 +1255,7 @@
             <a:spLocks noGrp="1"/>
           </p:cNvSpPr>
           <p:nvPr>
-            <p:ph type="dt" idx="6" sz="half"/>
+            <p:ph type="dt" sz="half" idx="6"/>
           </p:nvPr>
         </p:nvSpPr>
         <p:spPr>
@@ -1218,7 +1285,9 @@
           <a:p>
             <a:fld id="{1D8BD707-D9CF-40AE-B4C6-C98DA3205C09}" type="datetimeFigureOut">
               <a:rPr lang="en-US"/>
+              <a:t>6/29/2026</a:t>
             </a:fld>
+            <a:endParaRPr lang="en-US"/>
           </a:p>
         </p:txBody>
       </p:sp>
@@ -1229,7 +1298,7 @@
             <a:spLocks noGrp="1"/>
           </p:cNvSpPr>
           <p:nvPr>
-            <p:ph type="sldNum" idx="7" sz="quarter"/>
+            <p:ph type="sldNum" sz="quarter" idx="7"/>
           </p:nvPr>
         </p:nvSpPr>
         <p:spPr>
@@ -1258,14 +1327,15 @@
           </a:lstStyle>
           <a:p>
             <a:fld id="{B6F15528-21DE-4FAA-801E-634DDDAF4B2B}" type="slidenum">
-              <a:t>#</a:t>
+              <a:t>‹#›</a:t>
             </a:fld>
+            <a:endParaRPr/>
           </a:p>
         </p:txBody>
       </p:sp>
     </p:spTree>
   </p:cSld>
-  <p:clrMap folHlink="folHlink" hlink="hlink" accent1="accent1" accent2="accent2" accent3="accent3" accent4="accent4" accent5="accent5" accent6="accent6" tx2="dk2" bg2="lt2" tx1="dk1" bg1="lt1"/>
+  <p:clrMap bg1="lt1" tx1="dk1" bg2="lt2" tx2="dk2" accent1="accent1" accent2="accent2" accent3="accent3" accent4="accent4" accent5="accent5" accent6="accent6" hlink="hlink" folHlink="folHlink"/>
   <p:sldLayoutIdLst>
     <p:sldLayoutId id="2147483661" r:id="rId1"/>
     <p:sldLayoutId id="2147483662" r:id="rId2"/>
@@ -1465,14 +1535,14 @@
         <p:spPr>
           <a:xfrm>
             <a:off x="411480" y="4251960"/>
-            <a:ext cx="5394960" cy="2286000"/>
+            <a:ext cx="5394960" cy="2103140"/>
           </a:xfrm>
           <a:prstGeom prst="rect">
             <a:avLst/>
           </a:prstGeom>
         </p:spPr>
         <p:txBody>
-          <a:bodyPr wrap="square" lIns="0" tIns="12700" rIns="0" bIns="0" rtlCol="0" vert="horz">
+          <a:bodyPr vert="horz" wrap="square" lIns="0" tIns="12700" rIns="0" bIns="0" rtlCol="0">
             <a:spAutoFit/>
           </a:bodyPr>
           <a:lstStyle/>
@@ -1485,23 +1555,54 @@
                 <a:spcPts val="100"/>
               </a:spcBef>
             </a:pPr>
-            <a:r>
-              <a:rPr sz="1600" b="1">
+            <a:endParaRPr lang="en-IN" sz="1600" b="1" dirty="0">
+              <a:solidFill>
+                <a:srgbClr val="1A1A2E"/>
+              </a:solidFill>
+            </a:endParaRPr>
+          </a:p>
+          <a:p>
+            <a:pPr marL="17780" algn="l">
+              <a:lnSpc>
+                <a:spcPct val="100000"/>
+              </a:lnSpc>
+              <a:spcBef>
+                <a:spcPts val="100"/>
+              </a:spcBef>
+            </a:pPr>
+            <a:r>
+              <a:rPr sz="1600" b="1" dirty="0">
                 <a:solidFill>
                   <a:srgbClr val="1A1A2E"/>
                 </a:solidFill>
               </a:rPr>
-              <a:t>Team Name:  HackerX</a:t>
-            </a:r>
-            <a:endParaRPr sz="1800">
+              <a:t>Team Name:  </a:t>
+            </a:r>
+            <a:r>
+              <a:rPr sz="1600" b="1" dirty="0" err="1">
+                <a:solidFill>
+                  <a:srgbClr val="1A1A2E"/>
+                </a:solidFill>
+              </a:rPr>
+              <a:t>HackerX</a:t>
+            </a:r>
+            <a:endParaRPr sz="1800" dirty="0">
               <a:latin typeface="Calibri"/>
               <a:cs typeface="Calibri"/>
             </a:endParaRPr>
           </a:p>
           <a:p>
             <a:pPr algn="l"/>
-            <a:r>
-              <a:rPr sz="1400" b="0">
+            <a:endParaRPr lang="en-IN" sz="1400" b="0" dirty="0">
+              <a:solidFill>
+                <a:srgbClr val="1A1A1A"/>
+              </a:solidFill>
+            </a:endParaRPr>
+          </a:p>
+          <a:p>
+            <a:pPr algn="l"/>
+            <a:r>
+              <a:rPr sz="1400" b="0" dirty="0">
                 <a:solidFill>
                   <a:srgbClr val="1A1A1A"/>
                 </a:solidFill>
@@ -1511,19 +1612,16 @@
           </a:p>
           <a:p>
             <a:pPr algn="l"/>
-            <a:r>
-              <a:rPr sz="500" b="0">
-                <a:solidFill>
-                  <a:srgbClr val="1A1A1A"/>
-                </a:solidFill>
-              </a:rPr>
-              <a:t/>
-            </a:r>
-          </a:p>
-          <a:p>
-            <a:pPr algn="l"/>
-            <a:r>
-              <a:rPr sz="1300" b="1">
+            <a:endParaRPr sz="1400" b="0" dirty="0">
+              <a:solidFill>
+                <a:srgbClr val="1A1A1A"/>
+              </a:solidFill>
+            </a:endParaRPr>
+          </a:p>
+          <a:p>
+            <a:pPr algn="l"/>
+            <a:r>
+              <a:rPr sz="1300" b="1" dirty="0">
                 <a:solidFill>
                   <a:srgbClr val="5C337F"/>
                 </a:solidFill>
@@ -1534,7 +1632,7 @@
           <a:p>
             <a:pPr algn="l"/>
             <a:r>
-              <a:rPr sz="1200" b="0">
+              <a:rPr sz="1200" b="0" dirty="0">
                 <a:solidFill>
                   <a:srgbClr val="1A1A1A"/>
                 </a:solidFill>
@@ -1571,21 +1669,21 @@
       </p:grpSpPr>
       <p:sp>
         <p:nvSpPr>
-          <p:cNvPr id="2" name="object 2"/>
-          <p:cNvSpPr txBox="1"/>
-          <p:nvPr/>
-        </p:nvSpPr>
-        <p:spPr>
-          <a:xfrm>
-            <a:off x="-5486400" y="1171447"/>
-            <a:ext cx="835660" cy="254000"/>
-          </a:xfrm>
+          <p:cNvPr id="4" name="object 4" descr="$PPTXTitle"/>
+          <p:cNvSpPr txBox="1">
+            <a:spLocks noGrp="1"/>
+          </p:cNvSpPr>
+          <p:nvPr>
+            <p:ph type="title"/>
+          </p:nvPr>
+        </p:nvSpPr>
+        <p:spPr>
           <a:prstGeom prst="rect">
             <a:avLst/>
           </a:prstGeom>
         </p:spPr>
         <p:txBody>
-          <a:bodyPr wrap="square" lIns="0" tIns="12700" rIns="0" bIns="0" rtlCol="0" vert="horz">
+          <a:bodyPr vert="horz" wrap="square" lIns="0" tIns="12700" rIns="0" bIns="0" rtlCol="0">
             <a:spAutoFit/>
           </a:bodyPr>
           <a:lstStyle/>
@@ -1599,137 +1697,7 @@
               </a:spcBef>
             </a:pPr>
             <a:r>
-              <a:rPr dirty="0" sz="1500">
-                <a:solidFill>
-                  <a:srgbClr val="FFFFFF"/>
-                </a:solidFill>
-                <a:latin typeface="Calibri"/>
-                <a:cs typeface="Calibri"/>
-              </a:rPr>
-              <a:t>Ø</a:t>
-            </a:r>
-            <a:r>
-              <a:rPr dirty="0" sz="1500" spc="80">
-                <a:solidFill>
-                  <a:srgbClr val="FFFFFF"/>
-                </a:solidFill>
-                <a:latin typeface="Calibri"/>
-                <a:cs typeface="Calibri"/>
-              </a:rPr>
-              <a:t>  </a:t>
-            </a:r>
-            <a:r>
-              <a:rPr dirty="0" sz="1500" spc="40">
-                <a:solidFill>
-                  <a:srgbClr val="FFFFFF"/>
-                </a:solidFill>
-                <a:latin typeface="Calibri"/>
-                <a:cs typeface="Calibri"/>
-              </a:rPr>
-              <a:t>redrob</a:t>
-            </a:r>
-            <a:endParaRPr sz="1500">
-              <a:latin typeface="Calibri"/>
-              <a:cs typeface="Calibri"/>
-            </a:endParaRPr>
-          </a:p>
-        </p:txBody>
-      </p:sp>
-      <p:sp>
-        <p:nvSpPr>
-          <p:cNvPr id="3" name="object 3"/>
-          <p:cNvSpPr txBox="1"/>
-          <p:nvPr/>
-        </p:nvSpPr>
-        <p:spPr>
-          <a:xfrm>
-            <a:off x="-5486400" y="1171447"/>
-            <a:ext cx="371475" cy="254000"/>
-          </a:xfrm>
-          <a:prstGeom prst="rect">
-            <a:avLst/>
-          </a:prstGeom>
-        </p:spPr>
-        <p:txBody>
-          <a:bodyPr wrap="square" lIns="0" tIns="12700" rIns="0" bIns="0" rtlCol="0" vert="horz">
-            <a:spAutoFit/>
-          </a:bodyPr>
-          <a:lstStyle/>
-          <a:p>
-            <a:pPr marL="12700">
-              <a:lnSpc>
-                <a:spcPct val="100000"/>
-              </a:lnSpc>
-              <a:spcBef>
-                <a:spcPts val="100"/>
-              </a:spcBef>
-            </a:pPr>
-            <a:r>
-              <a:rPr dirty="0" sz="1500">
-                <a:solidFill>
-                  <a:srgbClr val="FFFFFF"/>
-                </a:solidFill>
-                <a:latin typeface="Calibri"/>
-                <a:cs typeface="Calibri"/>
-              </a:rPr>
-              <a:t>i</a:t>
-            </a:r>
-            <a:r>
-              <a:rPr dirty="0" sz="1500" spc="70">
-                <a:solidFill>
-                  <a:srgbClr val="FFFFFF"/>
-                </a:solidFill>
-                <a:latin typeface="Calibri"/>
-                <a:cs typeface="Calibri"/>
-              </a:rPr>
-              <a:t> </a:t>
-            </a:r>
-            <a:r>
-              <a:rPr dirty="0" sz="1500" spc="-25">
-                <a:solidFill>
-                  <a:srgbClr val="FFFFFF"/>
-                </a:solidFill>
-                <a:latin typeface="Calibri"/>
-                <a:cs typeface="Calibri"/>
-              </a:rPr>
-              <a:t>i2S</a:t>
-            </a:r>
-            <a:endParaRPr sz="1500">
-              <a:latin typeface="Calibri"/>
-              <a:cs typeface="Calibri"/>
-            </a:endParaRPr>
-          </a:p>
-        </p:txBody>
-      </p:sp>
-      <p:sp>
-        <p:nvSpPr>
-          <p:cNvPr id="4" name="object 4" descr="$PPTXTitle"/>
-          <p:cNvSpPr txBox="1">
-            <a:spLocks noGrp="1"/>
-          </p:cNvSpPr>
-          <p:nvPr>
-            <p:ph type="title"/>
-          </p:nvPr>
-        </p:nvSpPr>
-        <p:spPr>
-          <a:prstGeom prst="rect"/>
-        </p:spPr>
-        <p:txBody>
-          <a:bodyPr wrap="square" lIns="0" tIns="12700" rIns="0" bIns="0" rtlCol="0" vert="horz">
-            <a:spAutoFit/>
-          </a:bodyPr>
-          <a:lstStyle/>
-          <a:p>
-            <a:pPr marL="12700">
-              <a:lnSpc>
-                <a:spcPct val="100000"/>
-              </a:lnSpc>
-              <a:spcBef>
-                <a:spcPts val="100"/>
-              </a:spcBef>
-            </a:pPr>
-            <a:r>
-              <a:rPr dirty="0" spc="-35"/>
+              <a:rPr spc="-35" dirty="0"/>
               <a:t>INDIA.RUNS</a:t>
             </a:r>
           </a:p>
@@ -1751,7 +1719,7 @@
           </a:prstGeom>
         </p:spPr>
         <p:txBody>
-          <a:bodyPr wrap="square" lIns="0" tIns="12700" rIns="0" bIns="0" rtlCol="0" vert="horz">
+          <a:bodyPr vert="horz" wrap="square" lIns="0" tIns="12700" rIns="0" bIns="0" rtlCol="0">
             <a:spAutoFit/>
           </a:bodyPr>
           <a:lstStyle/>
@@ -1779,14 +1747,51 @@
           </a:p>
           <a:p>
             <a:pPr algn="l"/>
-            <a:r>
-              <a:rPr sz="400" b="0">
+            <a:endParaRPr sz="1750">
+              <a:latin typeface="Calibri"/>
+              <a:cs typeface="Calibri"/>
+            </a:endParaRPr>
+          </a:p>
+          <a:p>
+            <a:pPr algn="l"/>
+            <a:r>
+              <a:rPr sz="1300" b="1">
+                <a:solidFill>
+                  <a:srgbClr val="5C337F"/>
+                </a:solidFill>
+              </a:rPr>
+              <a:t>  ▸  GitHub Repository</a:t>
+            </a:r>
+          </a:p>
+          <a:p>
+            <a:pPr algn="l"/>
+            <a:r>
+              <a:rPr sz="1200" b="0">
                 <a:solidFill>
                   <a:srgbClr val="1A1A1A"/>
                 </a:solidFill>
               </a:rPr>
-              <a:t/>
-            </a:r>
+              <a:t>     github.com/suriyaprakash-25/redrob-ranker</a:t>
+            </a:r>
+          </a:p>
+          <a:p>
+            <a:pPr algn="l"/>
+            <a:r>
+              <a:rPr sz="1100" b="0">
+                <a:solidFill>
+                  <a:srgbClr val="555555"/>
+                </a:solidFill>
+              </a:rPr>
+              <a:t>     Full source code + commit history showing iterative, validation-driven development</a:t>
+            </a:r>
+          </a:p>
+          <a:p>
+            <a:pPr algn="l"/>
+            <a:endParaRPr sz="1100" b="0">
+              <a:solidFill>
+                <a:srgbClr val="555555"/>
+              </a:solidFill>
+            </a:endParaRPr>
           </a:p>
           <a:p>
             <a:pPr algn="l"/>
@@ -1796,7 +1801,7 @@
                   <a:srgbClr val="5C337F"/>
                 </a:solidFill>
               </a:rPr>
-              <a:t>  ▸  GitHub Repository</a:t>
+              <a:t>  ▸  HF Spaces Live Demo</a:t>
             </a:r>
           </a:p>
           <a:p>
@@ -1807,7 +1812,7 @@
                   <a:srgbClr val="1A1A1A"/>
                 </a:solidFill>
               </a:rPr>
-              <a:t>     github.com/suriyaprakash-25/redrob-ranker</a:t>
+              <a:t>     huggingface.co/spaces/Suriya-25/redrob-ranker</a:t>
             </a:r>
           </a:p>
           <a:p>
@@ -1818,19 +1823,57 @@
                   <a:srgbClr val="555555"/>
                 </a:solidFill>
               </a:rPr>
-              <a:t>     Full source code + commit history showing iterative, validation-driven development</a:t>
-            </a:r>
-          </a:p>
-          <a:p>
-            <a:pPr algn="l"/>
-            <a:r>
-              <a:rPr sz="200" b="0">
+              <a:t>     Interactive sandbox — click 'Run Pipeline' to execute on a 50-candidate sample.  Both runs produce identical deterministic output.</a:t>
+            </a:r>
+          </a:p>
+          <a:p>
+            <a:pPr algn="l"/>
+            <a:endParaRPr sz="1100" b="0">
+              <a:solidFill>
+                <a:srgbClr val="555555"/>
+              </a:solidFill>
+            </a:endParaRPr>
+          </a:p>
+          <a:p>
+            <a:pPr algn="l"/>
+            <a:r>
+              <a:rPr sz="1300" b="1">
+                <a:solidFill>
+                  <a:srgbClr val="5C337F"/>
+                </a:solidFill>
+              </a:rPr>
+              <a:t>  ▸  submission.csv</a:t>
+            </a:r>
+          </a:p>
+          <a:p>
+            <a:pPr algn="l"/>
+            <a:r>
+              <a:rPr sz="1200" b="0">
                 <a:solidFill>
                   <a:srgbClr val="1A1A1A"/>
                 </a:solidFill>
               </a:rPr>
-              <a:t/>
-            </a:r>
+              <a:t>     100 candidates — candidate_id | rank | score | reasoning</a:t>
+            </a:r>
+          </a:p>
+          <a:p>
+            <a:pPr algn="l"/>
+            <a:r>
+              <a:rPr sz="1100" b="0">
+                <a:solidFill>
+                  <a:srgbClr val="555555"/>
+                </a:solidFill>
+              </a:rPr>
+              <a:t>     Primary deliverable; passes validate_submission.py</a:t>
+            </a:r>
+          </a:p>
+          <a:p>
+            <a:pPr algn="l"/>
+            <a:endParaRPr sz="1100" b="0">
+              <a:solidFill>
+                <a:srgbClr val="555555"/>
+              </a:solidFill>
+            </a:endParaRPr>
           </a:p>
           <a:p>
             <a:pPr algn="l"/>
@@ -1840,7 +1883,7 @@
                   <a:srgbClr val="5C337F"/>
                 </a:solidFill>
               </a:rPr>
-              <a:t>  ▸  HF Spaces Live Demo</a:t>
+              <a:t>  ▸  submission_metadata.yaml</a:t>
             </a:r>
           </a:p>
           <a:p>
@@ -1851,7 +1894,7 @@
                   <a:srgbClr val="1A1A1A"/>
                 </a:solidFill>
               </a:rPr>
-              <a:t>     huggingface.co/spaces/Suriya-25/redrob-ranker</a:t>
+              <a:t>     Team: HackerX  ·  Leader: SURIYA PRAKASH R M  ·  Runtime: 61.8s</a:t>
             </a:r>
           </a:p>
           <a:p>
@@ -1862,19 +1905,57 @@
                   <a:srgbClr val="555555"/>
                 </a:solidFill>
               </a:rPr>
-              <a:t>     Interactive sandbox — click 'Run Pipeline' to execute on a 50-candidate sample.  Both runs produce identical deterministic output.</a:t>
-            </a:r>
-          </a:p>
-          <a:p>
-            <a:pPr algn="l"/>
-            <a:r>
-              <a:rPr sz="200" b="0">
+              <a:t>     Contact: suriyaprakashrm25@gmail.com</a:t>
+            </a:r>
+          </a:p>
+          <a:p>
+            <a:pPr algn="l"/>
+            <a:endParaRPr sz="1100" b="0">
+              <a:solidFill>
+                <a:srgbClr val="555555"/>
+              </a:solidFill>
+            </a:endParaRPr>
+          </a:p>
+          <a:p>
+            <a:pPr algn="l"/>
+            <a:r>
+              <a:rPr sz="1300" b="1">
+                <a:solidFill>
+                  <a:srgbClr val="5C337F"/>
+                </a:solidFill>
+              </a:rPr>
+              <a:t>  ▸  VALIDATION_LOG.md</a:t>
+            </a:r>
+          </a:p>
+          <a:p>
+            <a:pPr algn="l"/>
+            <a:r>
+              <a:rPr sz="1200" b="0">
                 <a:solidFill>
                   <a:srgbClr val="1A1A1A"/>
                 </a:solidFill>
               </a:rPr>
-              <a:t/>
-            </a:r>
+              <a:t>     Audit trail — every bug found and fixed against the real 100K dataset</a:t>
+            </a:r>
+          </a:p>
+          <a:p>
+            <a:pPr algn="l"/>
+            <a:r>
+              <a:rPr sz="1100" b="0">
+                <a:solidFill>
+                  <a:srgbClr val="555555"/>
+                </a:solidFill>
+              </a:rPr>
+              <a:t>     6 real bugs documented with root cause, fix, and before/after metrics</a:t>
+            </a:r>
+          </a:p>
+          <a:p>
+            <a:pPr algn="l"/>
+            <a:endParaRPr sz="1100" b="0">
+              <a:solidFill>
+                <a:srgbClr val="555555"/>
+              </a:solidFill>
+            </a:endParaRPr>
           </a:p>
           <a:p>
             <a:pPr algn="l"/>
@@ -1884,7 +1965,7 @@
                   <a:srgbClr val="5C337F"/>
                 </a:solidFill>
               </a:rPr>
-              <a:t>  ▸  submission.csv</a:t>
+              <a:t>  ▸  FINAL_VALIDATION_REPORT.md</a:t>
             </a:r>
           </a:p>
           <a:p>
@@ -1895,7 +1976,7 @@
                   <a:srgbClr val="1A1A1A"/>
                 </a:solidFill>
               </a:rPr>
-              <a:t>     100 candidates — candidate_id | rank | score | reasoning</a:t>
+              <a:t>     Post-fix consolidated verification — all deck numbers trace here</a:t>
             </a:r>
           </a:p>
           <a:p>
@@ -1906,157 +1987,22 @@
                   <a:srgbClr val="555555"/>
                 </a:solidFill>
               </a:rPr>
-              <a:t>     Primary deliverable; passes validate_submission.py</a:t>
-            </a:r>
-          </a:p>
-          <a:p>
-            <a:pPr algn="l"/>
-            <a:r>
-              <a:rPr sz="200" b="0">
-                <a:solidFill>
-                  <a:srgbClr val="1A1A1A"/>
-                </a:solidFill>
-              </a:rPr>
-              <a:t/>
-            </a:r>
-          </a:p>
-          <a:p>
-            <a:pPr algn="l"/>
-            <a:r>
-              <a:rPr sz="1300" b="1">
-                <a:solidFill>
-                  <a:srgbClr val="5C337F"/>
-                </a:solidFill>
-              </a:rPr>
-              <a:t>  ▸  submission_metadata.yaml</a:t>
-            </a:r>
-          </a:p>
-          <a:p>
-            <a:pPr algn="l"/>
-            <a:r>
-              <a:rPr sz="1200" b="0">
-                <a:solidFill>
-                  <a:srgbClr val="1A1A1A"/>
-                </a:solidFill>
-              </a:rPr>
-              <a:t>     Team: HackerX  ·  Leader: SURIYA PRAKASH R M  ·  Runtime: 61.8s</a:t>
-            </a:r>
-          </a:p>
-          <a:p>
-            <a:pPr algn="l"/>
-            <a:r>
-              <a:rPr sz="1100" b="0">
-                <a:solidFill>
-                  <a:srgbClr val="555555"/>
-                </a:solidFill>
-              </a:rPr>
-              <a:t>     Contact: suriyaprakashrm25@gmail.com</a:t>
-            </a:r>
-          </a:p>
-          <a:p>
-            <a:pPr algn="l"/>
-            <a:r>
-              <a:rPr sz="200" b="0">
-                <a:solidFill>
-                  <a:srgbClr val="1A1A1A"/>
-                </a:solidFill>
-              </a:rPr>
-              <a:t/>
-            </a:r>
-          </a:p>
-          <a:p>
-            <a:pPr algn="l"/>
-            <a:r>
-              <a:rPr sz="1300" b="1">
-                <a:solidFill>
-                  <a:srgbClr val="5C337F"/>
-                </a:solidFill>
-              </a:rPr>
-              <a:t>  ▸  VALIDATION_LOG.md</a:t>
-            </a:r>
-          </a:p>
-          <a:p>
-            <a:pPr algn="l"/>
-            <a:r>
-              <a:rPr sz="1200" b="0">
-                <a:solidFill>
-                  <a:srgbClr val="1A1A1A"/>
-                </a:solidFill>
-              </a:rPr>
-              <a:t>     Audit trail — every bug found and fixed against the real 100K dataset</a:t>
-            </a:r>
-          </a:p>
-          <a:p>
-            <a:pPr algn="l"/>
-            <a:r>
-              <a:rPr sz="1100" b="0">
-                <a:solidFill>
-                  <a:srgbClr val="555555"/>
-                </a:solidFill>
-              </a:rPr>
-              <a:t>     6 real bugs documented with root cause, fix, and before/after metrics</a:t>
-            </a:r>
-          </a:p>
-          <a:p>
-            <a:pPr algn="l"/>
-            <a:r>
-              <a:rPr sz="200" b="0">
-                <a:solidFill>
-                  <a:srgbClr val="1A1A1A"/>
-                </a:solidFill>
-              </a:rPr>
-              <a:t/>
-            </a:r>
-          </a:p>
-          <a:p>
-            <a:pPr algn="l"/>
-            <a:r>
-              <a:rPr sz="1300" b="1">
-                <a:solidFill>
-                  <a:srgbClr val="5C337F"/>
-                </a:solidFill>
-              </a:rPr>
-              <a:t>  ▸  FINAL_VALIDATION_REPORT.md</a:t>
-            </a:r>
-          </a:p>
-          <a:p>
-            <a:pPr algn="l"/>
-            <a:r>
-              <a:rPr sz="1200" b="0">
-                <a:solidFill>
-                  <a:srgbClr val="1A1A1A"/>
-                </a:solidFill>
-              </a:rPr>
-              <a:t>     Post-fix consolidated verification — all deck numbers trace here</a:t>
-            </a:r>
-          </a:p>
-          <a:p>
-            <a:pPr algn="l"/>
-            <a:r>
-              <a:rPr sz="1100" b="0">
-                <a:solidFill>
-                  <a:srgbClr val="555555"/>
-                </a:solidFill>
-              </a:rPr>
               <a:t>     Gold ranks · trap scores · honeypot count · reasoning spot-check · runtime</a:t>
             </a:r>
           </a:p>
           <a:p>
             <a:pPr algn="l"/>
-            <a:r>
-              <a:rPr sz="200" b="0">
-                <a:solidFill>
-                  <a:srgbClr val="1A1A1A"/>
-                </a:solidFill>
-              </a:rPr>
-              <a:t/>
-            </a:r>
+            <a:endParaRPr sz="1100" b="0">
+              <a:solidFill>
+                <a:srgbClr val="555555"/>
+              </a:solidFill>
+            </a:endParaRPr>
           </a:p>
         </p:txBody>
       </p:sp>
       <p:pic>
         <p:nvPicPr>
-          <p:cNvPr id="6" name="Picture 5" descr="logos_transparent.png"/>
+          <p:cNvPr id="6" name="Picture 5" descr="logos_clean.png"/>
           <p:cNvPicPr>
             <a:picLocks noChangeAspect="1"/>
           </p:cNvPicPr>
@@ -2070,8 +2016,8 @@
         </p:blipFill>
         <p:spPr>
           <a:xfrm>
-            <a:off x="256032" y="1060704"/>
-            <a:ext cx="1816377" cy="512064"/>
+            <a:off x="256032" y="1049731"/>
+            <a:ext cx="1819656" cy="502920"/>
           </a:xfrm>
           <a:prstGeom prst="rect">
             <a:avLst/>
@@ -2103,111 +2049,6 @@
           <a:chExt cx="0" cy="0"/>
         </a:xfrm>
       </p:grpSpPr>
-      <p:sp>
-        <p:nvSpPr>
-          <p:cNvPr id="2" name="object 2"/>
-          <p:cNvSpPr txBox="1"/>
-          <p:nvPr/>
-        </p:nvSpPr>
-        <p:spPr>
-          <a:xfrm>
-            <a:off x="-5486400" y="2016871"/>
-            <a:ext cx="922019" cy="387350"/>
-          </a:xfrm>
-          <a:prstGeom prst="rect">
-            <a:avLst/>
-          </a:prstGeom>
-        </p:spPr>
-        <p:txBody>
-          <a:bodyPr wrap="square" lIns="0" tIns="15875" rIns="0" bIns="0" rtlCol="0" vert="horz">
-            <a:spAutoFit/>
-          </a:bodyPr>
-          <a:lstStyle/>
-          <a:p>
-            <a:pPr marL="12700">
-              <a:lnSpc>
-                <a:spcPct val="100000"/>
-              </a:lnSpc>
-              <a:spcBef>
-                <a:spcPts val="125"/>
-              </a:spcBef>
-            </a:pPr>
-            <a:r>
-              <a:rPr dirty="0" sz="2350" spc="-10">
-                <a:solidFill>
-                  <a:srgbClr val="FFFFFF"/>
-                </a:solidFill>
-                <a:latin typeface="Arial MT"/>
-                <a:cs typeface="Arial MT"/>
-              </a:rPr>
-              <a:t>redrob</a:t>
-            </a:r>
-            <a:endParaRPr sz="2350">
-              <a:latin typeface="Arial MT"/>
-              <a:cs typeface="Arial MT"/>
-            </a:endParaRPr>
-          </a:p>
-        </p:txBody>
-      </p:sp>
-      <p:sp>
-        <p:nvSpPr>
-          <p:cNvPr id="3" name="object 3" descr="$PPTXTitle"/>
-          <p:cNvSpPr txBox="1">
-            <a:spLocks noGrp="1"/>
-          </p:cNvSpPr>
-          <p:nvPr>
-            <p:ph type="title"/>
-          </p:nvPr>
-        </p:nvSpPr>
-        <p:spPr>
-          <a:xfrm>
-            <a:off x="-5486400" y="2016871"/>
-            <a:ext cx="642620" cy="387350"/>
-          </a:xfrm>
-          <a:prstGeom prst="rect"/>
-        </p:spPr>
-        <p:txBody>
-          <a:bodyPr wrap="square" lIns="0" tIns="15875" rIns="0" bIns="0" rtlCol="0" vert="horz">
-            <a:spAutoFit/>
-          </a:bodyPr>
-          <a:lstStyle/>
-          <a:p>
-            <a:pPr marL="12700">
-              <a:lnSpc>
-                <a:spcPct val="100000"/>
-              </a:lnSpc>
-              <a:spcBef>
-                <a:spcPts val="125"/>
-              </a:spcBef>
-            </a:pPr>
-            <a:r>
-              <a:rPr dirty="0" sz="2350" i="0">
-                <a:latin typeface="Arial MT"/>
-                <a:cs typeface="Arial MT"/>
-              </a:rPr>
-              <a:t>i</a:t>
-            </a:r>
-            <a:r>
-              <a:rPr dirty="0" sz="2350" spc="15" i="0">
-                <a:latin typeface="Arial MT"/>
-                <a:cs typeface="Arial MT"/>
-              </a:rPr>
-              <a:t> </a:t>
-            </a:r>
-            <a:r>
-              <a:rPr dirty="0" sz="2350" spc="-25" i="0">
-                <a:latin typeface="Arial MT"/>
-                <a:cs typeface="Arial MT"/>
-              </a:rPr>
-              <a:t>iZS</a:t>
-            </a:r>
-            <a:endParaRPr sz="2350">
-              <a:latin typeface="Arial MT"/>
-              <a:cs typeface="Arial MT"/>
-            </a:endParaRPr>
-          </a:p>
-        </p:txBody>
-      </p:sp>
       <p:pic>
         <p:nvPicPr>
           <p:cNvPr id="4" name="Picture 3" descr="logos_s11.png"/>
@@ -2226,6 +2067,36 @@
           <a:xfrm>
             <a:off x="3074862" y="2020824"/>
             <a:ext cx="3908675" cy="384048"/>
+          </a:xfrm>
+          <a:prstGeom prst="rect">
+            <a:avLst/>
+          </a:prstGeom>
+        </p:spPr>
+      </p:pic>
+      <p:pic>
+        <p:nvPicPr>
+          <p:cNvPr id="8" name="Picture 7">
+            <a:extLst>
+              <a:ext uri="{FF2B5EF4-FFF2-40B4-BE49-F238E27FC236}">
+                <a16:creationId xmlns:a16="http://schemas.microsoft.com/office/drawing/2014/main" id="{CB3DDCAE-F8BF-1302-E630-3C735ABCFBDA}"/>
+              </a:ext>
+            </a:extLst>
+          </p:cNvPr>
+          <p:cNvPicPr>
+            <a:picLocks noChangeAspect="1"/>
+          </p:cNvPicPr>
+          <p:nvPr/>
+        </p:nvPicPr>
+        <p:blipFill>
+          <a:blip r:embed="rId3"/>
+          <a:stretch>
+            <a:fillRect/>
+          </a:stretch>
+        </p:blipFill>
+        <p:spPr>
+          <a:xfrm>
+            <a:off x="0" y="0"/>
+            <a:ext cx="10058400" cy="7772400"/>
           </a:xfrm>
           <a:prstGeom prst="rect">
             <a:avLst/>
@@ -2259,21 +2130,21 @@
       </p:grpSpPr>
       <p:sp>
         <p:nvSpPr>
-          <p:cNvPr id="2" name="object 2"/>
-          <p:cNvSpPr txBox="1"/>
-          <p:nvPr/>
-        </p:nvSpPr>
-        <p:spPr>
-          <a:xfrm>
-            <a:off x="-5486400" y="1171447"/>
-            <a:ext cx="835660" cy="254000"/>
-          </a:xfrm>
+          <p:cNvPr id="4" name="object 4" descr="$PPTXTitle"/>
+          <p:cNvSpPr txBox="1">
+            <a:spLocks noGrp="1"/>
+          </p:cNvSpPr>
+          <p:nvPr>
+            <p:ph type="title"/>
+          </p:nvPr>
+        </p:nvSpPr>
+        <p:spPr>
           <a:prstGeom prst="rect">
             <a:avLst/>
           </a:prstGeom>
         </p:spPr>
         <p:txBody>
-          <a:bodyPr wrap="square" lIns="0" tIns="12700" rIns="0" bIns="0" rtlCol="0" vert="horz">
+          <a:bodyPr vert="horz" wrap="square" lIns="0" tIns="12700" rIns="0" bIns="0" rtlCol="0">
             <a:spAutoFit/>
           </a:bodyPr>
           <a:lstStyle/>
@@ -2287,137 +2158,7 @@
               </a:spcBef>
             </a:pPr>
             <a:r>
-              <a:rPr dirty="0" sz="1500">
-                <a:solidFill>
-                  <a:srgbClr val="FFFFFF"/>
-                </a:solidFill>
-                <a:latin typeface="Calibri"/>
-                <a:cs typeface="Calibri"/>
-              </a:rPr>
-              <a:t>Ø</a:t>
-            </a:r>
-            <a:r>
-              <a:rPr dirty="0" sz="1500" spc="80">
-                <a:solidFill>
-                  <a:srgbClr val="FFFFFF"/>
-                </a:solidFill>
-                <a:latin typeface="Calibri"/>
-                <a:cs typeface="Calibri"/>
-              </a:rPr>
-              <a:t>  </a:t>
-            </a:r>
-            <a:r>
-              <a:rPr dirty="0" sz="1500" spc="40">
-                <a:solidFill>
-                  <a:srgbClr val="FFFFFF"/>
-                </a:solidFill>
-                <a:latin typeface="Calibri"/>
-                <a:cs typeface="Calibri"/>
-              </a:rPr>
-              <a:t>redrob</a:t>
-            </a:r>
-            <a:endParaRPr sz="1500">
-              <a:latin typeface="Calibri"/>
-              <a:cs typeface="Calibri"/>
-            </a:endParaRPr>
-          </a:p>
-        </p:txBody>
-      </p:sp>
-      <p:sp>
-        <p:nvSpPr>
-          <p:cNvPr id="3" name="object 3"/>
-          <p:cNvSpPr txBox="1"/>
-          <p:nvPr/>
-        </p:nvSpPr>
-        <p:spPr>
-          <a:xfrm>
-            <a:off x="-5486400" y="1171447"/>
-            <a:ext cx="371475" cy="254000"/>
-          </a:xfrm>
-          <a:prstGeom prst="rect">
-            <a:avLst/>
-          </a:prstGeom>
-        </p:spPr>
-        <p:txBody>
-          <a:bodyPr wrap="square" lIns="0" tIns="12700" rIns="0" bIns="0" rtlCol="0" vert="horz">
-            <a:spAutoFit/>
-          </a:bodyPr>
-          <a:lstStyle/>
-          <a:p>
-            <a:pPr marL="12700">
-              <a:lnSpc>
-                <a:spcPct val="100000"/>
-              </a:lnSpc>
-              <a:spcBef>
-                <a:spcPts val="100"/>
-              </a:spcBef>
-            </a:pPr>
-            <a:r>
-              <a:rPr dirty="0" sz="1500">
-                <a:solidFill>
-                  <a:srgbClr val="FFFFFF"/>
-                </a:solidFill>
-                <a:latin typeface="Calibri"/>
-                <a:cs typeface="Calibri"/>
-              </a:rPr>
-              <a:t>i</a:t>
-            </a:r>
-            <a:r>
-              <a:rPr dirty="0" sz="1500" spc="70">
-                <a:solidFill>
-                  <a:srgbClr val="FFFFFF"/>
-                </a:solidFill>
-                <a:latin typeface="Calibri"/>
-                <a:cs typeface="Calibri"/>
-              </a:rPr>
-              <a:t> </a:t>
-            </a:r>
-            <a:r>
-              <a:rPr dirty="0" sz="1500" spc="-25">
-                <a:solidFill>
-                  <a:srgbClr val="FFFFFF"/>
-                </a:solidFill>
-                <a:latin typeface="Calibri"/>
-                <a:cs typeface="Calibri"/>
-              </a:rPr>
-              <a:t>i2S</a:t>
-            </a:r>
-            <a:endParaRPr sz="1500">
-              <a:latin typeface="Calibri"/>
-              <a:cs typeface="Calibri"/>
-            </a:endParaRPr>
-          </a:p>
-        </p:txBody>
-      </p:sp>
-      <p:sp>
-        <p:nvSpPr>
-          <p:cNvPr id="4" name="object 4" descr="$PPTXTitle"/>
-          <p:cNvSpPr txBox="1">
-            <a:spLocks noGrp="1"/>
-          </p:cNvSpPr>
-          <p:nvPr>
-            <p:ph type="title"/>
-          </p:nvPr>
-        </p:nvSpPr>
-        <p:spPr>
-          <a:prstGeom prst="rect"/>
-        </p:spPr>
-        <p:txBody>
-          <a:bodyPr wrap="square" lIns="0" tIns="12700" rIns="0" bIns="0" rtlCol="0" vert="horz">
-            <a:spAutoFit/>
-          </a:bodyPr>
-          <a:lstStyle/>
-          <a:p>
-            <a:pPr marL="12700">
-              <a:lnSpc>
-                <a:spcPct val="100000"/>
-              </a:lnSpc>
-              <a:spcBef>
-                <a:spcPts val="100"/>
-              </a:spcBef>
-            </a:pPr>
-            <a:r>
-              <a:rPr dirty="0" spc="-35"/>
+              <a:rPr spc="-35" dirty="0"/>
               <a:t>INDIA.RUNS</a:t>
             </a:r>
           </a:p>
@@ -2439,7 +2180,7 @@
           </a:prstGeom>
         </p:spPr>
         <p:txBody>
-          <a:bodyPr wrap="square" lIns="0" tIns="12700" rIns="0" bIns="0" rtlCol="0" vert="horz">
+          <a:bodyPr vert="horz" wrap="square" lIns="0" tIns="12700" rIns="0" bIns="0" rtlCol="0">
             <a:spAutoFit/>
           </a:bodyPr>
           <a:lstStyle/>
@@ -2467,23 +2208,19 @@
           </a:p>
           <a:p>
             <a:pPr algn="l"/>
-            <a:r>
-              <a:rPr sz="400" b="0">
+            <a:endParaRPr sz="1750">
+              <a:latin typeface="Arial MT"/>
+              <a:cs typeface="Arial MT"/>
+            </a:endParaRPr>
+          </a:p>
+          <a:p>
+            <a:pPr algn="l"/>
+            <a:r>
+              <a:rPr sz="1300" b="0">
                 <a:solidFill>
                   <a:srgbClr val="1A1A1A"/>
                 </a:solidFill>
               </a:rPr>
-              <a:t/>
-            </a:r>
-          </a:p>
-          <a:p>
-            <a:pPr algn="l"/>
-            <a:r>
-              <a:rPr sz="1300" b="0">
-                <a:solidFill>
-                  <a:srgbClr val="1A1A1A"/>
-                </a:solidFill>
-              </a:rPr>
               <a:t>Five-stage deterministic pipeline:  honeypot hard-gate  →  structured JD-fit scoring  →  TF-IDF/SVD semantic similarity on career-history prose  →  verified-vs-claimed trust multiplier  ×  behavioral availability modifier  →  fact-grounded reasoning</a:t>
             </a:r>
           </a:p>
@@ -2500,14 +2237,11 @@
           </a:p>
           <a:p>
             <a:pPr algn="l"/>
-            <a:r>
-              <a:rPr sz="500" b="0">
-                <a:solidFill>
-                  <a:srgbClr val="1A1A1A"/>
-                </a:solidFill>
-              </a:rPr>
-              <a:t/>
-            </a:r>
+            <a:endParaRPr sz="1300" b="1">
+              <a:solidFill>
+                <a:srgbClr val="00854A"/>
+              </a:solidFill>
+            </a:endParaRPr>
           </a:p>
           <a:p>
             <a:pPr algn="l"/>
@@ -2522,14 +2256,11 @@
           </a:p>
           <a:p>
             <a:pPr algn="l"/>
-            <a:r>
-              <a:rPr sz="200" b="0">
-                <a:solidFill>
-                  <a:srgbClr val="1A1A1A"/>
-                </a:solidFill>
-              </a:rPr>
-              <a:t/>
-            </a:r>
+            <a:endParaRPr sz="1400" b="1">
+              <a:solidFill>
+                <a:srgbClr val="16213E"/>
+              </a:solidFill>
+            </a:endParaRPr>
           </a:p>
           <a:p>
             <a:pPr algn="l"/>
@@ -2645,7 +2376,7 @@
       </p:sp>
       <p:pic>
         <p:nvPicPr>
-          <p:cNvPr id="6" name="Picture 5" descr="logos_transparent.png"/>
+          <p:cNvPr id="6" name="Picture 5" descr="logos_clean.png"/>
           <p:cNvPicPr>
             <a:picLocks noChangeAspect="1"/>
           </p:cNvPicPr>
@@ -2659,8 +2390,8 @@
         </p:blipFill>
         <p:spPr>
           <a:xfrm>
-            <a:off x="256032" y="1060704"/>
-            <a:ext cx="1816377" cy="512064"/>
+            <a:off x="256032" y="1049731"/>
+            <a:ext cx="1819656" cy="502920"/>
           </a:xfrm>
           <a:prstGeom prst="rect">
             <a:avLst/>
@@ -2694,12 +2425,14 @@
       </p:grpSpPr>
       <p:pic>
         <p:nvPicPr>
-          <p:cNvPr id="2" name="object 2"/>
-          <p:cNvPicPr/>
+          <p:cNvPr id="4" name="Picture 3" descr="image.png"/>
+          <p:cNvPicPr>
+            <a:picLocks noChangeAspect="1"/>
+          </p:cNvPicPr>
           <p:nvPr/>
         </p:nvPicPr>
         <p:blipFill>
-          <a:blip r:embed="rId2" cstate="print"/>
+          <a:blip r:embed="rId2"/>
           <a:stretch>
             <a:fillRect/>
           </a:stretch>
@@ -2730,7 +2463,7 @@
           </a:prstGeom>
         </p:spPr>
         <p:txBody>
-          <a:bodyPr wrap="square" lIns="0" tIns="12700" rIns="0" bIns="0" rtlCol="0" vert="horz">
+          <a:bodyPr vert="horz" wrap="square" lIns="0" tIns="12700" rIns="0" bIns="0" rtlCol="0">
             <a:spAutoFit/>
           </a:bodyPr>
           <a:lstStyle/>
@@ -2758,14 +2491,84 @@
           </a:p>
           <a:p>
             <a:pPr algn="l"/>
-            <a:r>
-              <a:rPr sz="400" b="0">
+            <a:endParaRPr sz="1750">
+              <a:latin typeface="Arial MT"/>
+              <a:cs typeface="Arial MT"/>
+            </a:endParaRPr>
+          </a:p>
+          <a:p>
+            <a:pPr algn="l"/>
+            <a:r>
+              <a:rPr sz="1400" b="1">
+                <a:solidFill>
+                  <a:srgbClr val="16213E"/>
+                </a:solidFill>
+              </a:rPr>
+              <a:t>4 Must-Have Skill Families  (MUST_HAVE_SKILL_FAMILIES in jd_requirements.py):</a:t>
+            </a:r>
+          </a:p>
+          <a:p>
+            <a:pPr algn="l"/>
+            <a:r>
+              <a:rPr sz="1200" b="0">
                 <a:solidFill>
                   <a:srgbClr val="1A1A1A"/>
                 </a:solidFill>
               </a:rPr>
-              <a:t/>
-            </a:r>
+              <a:t>  1  Embeddings &amp; Retrieval  —  sentence-transformers, BGE, E5, dense retrieval, semantic search, Haystack, LlamaIndex</a:t>
+            </a:r>
+          </a:p>
+          <a:p>
+            <a:pPr algn="l"/>
+            <a:r>
+              <a:rPr sz="1200" b="0">
+                <a:solidFill>
+                  <a:srgbClr val="1A1A1A"/>
+                </a:solidFill>
+              </a:rPr>
+              <a:t>  2  Vector / Hybrid Search Infrastructure  —  pgvector, FAISS, Elasticsearch, OpenSearch, Qdrant, Milvus, BM25, hybrid search</a:t>
+            </a:r>
+          </a:p>
+          <a:p>
+            <a:pPr algn="l"/>
+            <a:r>
+              <a:rPr sz="1200" b="0">
+                <a:solidFill>
+                  <a:srgbClr val="1A1A1A"/>
+                </a:solidFill>
+              </a:rPr>
+              <a:t>  3  Python  —  explicit JD requirement; absence is a scored gap regardless of other skills</a:t>
+            </a:r>
+          </a:p>
+          <a:p>
+            <a:pPr algn="l"/>
+            <a:r>
+              <a:rPr sz="1200" b="0">
+                <a:solidFill>
+                  <a:srgbClr val="1A1A1A"/>
+                </a:solidFill>
+              </a:rPr>
+              <a:t>  4  Ranking Evaluation Methodology  —  NDCG, MRR, MAP, A-B testing, learning to rank, recsys</a:t>
+            </a:r>
+          </a:p>
+          <a:p>
+            <a:pPr algn="l"/>
+            <a:r>
+              <a:rPr sz="1200" b="0">
+                <a:solidFill>
+                  <a:srgbClr val="B7450A"/>
+                </a:solidFill>
+              </a:rPr>
+              <a:t>  ✗  LLM fine-tuning / PEFT (LoRA, QLoRA)  —  NICE_TO_HAVE only; not a disqualifier if absent</a:t>
+            </a:r>
+          </a:p>
+          <a:p>
+            <a:pPr algn="l"/>
+            <a:endParaRPr sz="1200" b="0">
+              <a:solidFill>
+                <a:srgbClr val="B7450A"/>
+              </a:solidFill>
+            </a:endParaRPr>
           </a:p>
           <a:p>
             <a:pPr algn="l"/>
@@ -2775,7 +2578,7 @@
                   <a:srgbClr val="16213E"/>
                 </a:solidFill>
               </a:rPr>
-              <a:t>4 Must-Have Skill Families  (MUST_HAVE_SKILL_FAMILIES in jd_requirements.py):</a:t>
+              <a:t>Beyond keywords — 4 additional candidate signals:</a:t>
             </a:r>
           </a:p>
           <a:p>
@@ -2786,7 +2589,7 @@
                   <a:srgbClr val="1A1A1A"/>
                 </a:solidFill>
               </a:rPr>
-              <a:t>  1  Embeddings &amp; Retrieval  —  sentence-transformers, BGE, E5, dense retrieval, semantic search, Haystack, LlamaIndex</a:t>
+              <a:t>  Career-history PROSE (not skills list) — TF-IDF/SVD on the text of what candidates say they did</a:t>
             </a:r>
           </a:p>
           <a:p>
@@ -2797,7 +2600,7 @@
                   <a:srgbClr val="1A1A1A"/>
                 </a:solidFill>
               </a:rPr>
-              <a:t>  2  Vector / Hybrid Search Infrastructure  —  pgvector, FAISS, Elasticsearch, OpenSearch, Qdrant, Milvus, BM25, hybrid search</a:t>
+              <a:t>  Verified-vs-claimed — platform skill_assessment_scores vs. self-reported (34.3% diverge &gt;30 pts)</a:t>
             </a:r>
           </a:p>
           <a:p>
@@ -2808,7 +2611,7 @@
                   <a:srgbClr val="1A1A1A"/>
                 </a:solidFill>
               </a:rPr>
-              <a:t>  3  Python  —  explicit JD requirement; absence is a scored gap regardless of other skills</a:t>
+              <a:t>  Reachability — last_active_date, open_to_work_flag, recruiter_response_rate, interview_completion_rate</a:t>
             </a:r>
           </a:p>
           <a:p>
@@ -2819,96 +2622,16 @@
                   <a:srgbClr val="1A1A1A"/>
                 </a:solidFill>
               </a:rPr>
-              <a:t>  4  Ranking Evaluation Methodology  —  NDCG, MRR, MAP, A-B testing, learning to rank, recsys</a:t>
-            </a:r>
-          </a:p>
-          <a:p>
-            <a:pPr algn="l"/>
-            <a:r>
-              <a:rPr sz="1200" b="0">
-                <a:solidFill>
-                  <a:srgbClr val="B7450A"/>
-                </a:solidFill>
-              </a:rPr>
-              <a:t>  ✗  LLM fine-tuning / PEFT (LoRA, QLoRA)  —  NICE_TO_HAVE only; not a disqualifier if absent</a:t>
-            </a:r>
-          </a:p>
-          <a:p>
-            <a:pPr algn="l"/>
-            <a:r>
-              <a:rPr sz="400" b="0">
-                <a:solidFill>
-                  <a:srgbClr val="1A1A1A"/>
-                </a:solidFill>
-              </a:rPr>
-              <a:t/>
-            </a:r>
-          </a:p>
-          <a:p>
-            <a:pPr algn="l"/>
-            <a:r>
-              <a:rPr sz="1400" b="1">
-                <a:solidFill>
-                  <a:srgbClr val="16213E"/>
-                </a:solidFill>
-              </a:rPr>
-              <a:t>Beyond keywords — 4 additional candidate signals:</a:t>
-            </a:r>
-          </a:p>
-          <a:p>
-            <a:pPr algn="l"/>
-            <a:r>
-              <a:rPr sz="1200" b="0">
-                <a:solidFill>
-                  <a:srgbClr val="1A1A1A"/>
-                </a:solidFill>
-              </a:rPr>
-              <a:t>  Career-history PROSE (not skills list) — TF-IDF/SVD on the text of what candidates say they did</a:t>
-            </a:r>
-          </a:p>
-          <a:p>
-            <a:pPr algn="l"/>
-            <a:r>
-              <a:rPr sz="1200" b="0">
-                <a:solidFill>
-                  <a:srgbClr val="1A1A1A"/>
-                </a:solidFill>
-              </a:rPr>
-              <a:t>  Verified-vs-claimed — platform skill_assessment_scores vs. self-reported (34.3% diverge &gt;30 pts)</a:t>
-            </a:r>
-          </a:p>
-          <a:p>
-            <a:pPr algn="l"/>
-            <a:r>
-              <a:rPr sz="1200" b="0">
-                <a:solidFill>
-                  <a:srgbClr val="1A1A1A"/>
-                </a:solidFill>
-              </a:rPr>
-              <a:t>  Reachability — last_active_date, open_to_work_flag, recruiter_response_rate, interview_completion_rate</a:t>
-            </a:r>
-          </a:p>
-          <a:p>
-            <a:pPr algn="l"/>
-            <a:r>
-              <a:rPr sz="1200" b="0">
-                <a:solidFill>
-                  <a:srgbClr val="1A1A1A"/>
-                </a:solidFill>
-              </a:rPr>
               <a:t>  Internal consistency — date arithmetic, duration totals; fabricated profiles fail before scoring</a:t>
             </a:r>
           </a:p>
           <a:p>
             <a:pPr algn="l"/>
-            <a:r>
-              <a:rPr sz="400" b="0">
-                <a:solidFill>
-                  <a:srgbClr val="1A1A1A"/>
-                </a:solidFill>
-              </a:rPr>
-              <a:t/>
-            </a:r>
+            <a:endParaRPr sz="1200" b="0">
+              <a:solidFill>
+                <a:srgbClr val="1A1A1A"/>
+              </a:solidFill>
+            </a:endParaRPr>
           </a:p>
           <a:p>
             <a:pPr algn="l"/>
@@ -2972,12 +2695,14 @@
       </p:grpSpPr>
       <p:pic>
         <p:nvPicPr>
-          <p:cNvPr id="2" name="object 2"/>
-          <p:cNvPicPr/>
+          <p:cNvPr id="4" name="Picture 3" descr="image.png"/>
+          <p:cNvPicPr>
+            <a:picLocks noChangeAspect="1"/>
+          </p:cNvPicPr>
           <p:nvPr/>
         </p:nvPicPr>
         <p:blipFill>
-          <a:blip r:embed="rId2" cstate="print"/>
+          <a:blip r:embed="rId2"/>
           <a:stretch>
             <a:fillRect/>
           </a:stretch>
@@ -3008,7 +2733,7 @@
           </a:prstGeom>
         </p:spPr>
         <p:txBody>
-          <a:bodyPr wrap="square" lIns="0" tIns="12700" rIns="0" bIns="0" rtlCol="0" vert="horz">
+          <a:bodyPr vert="horz" wrap="square" lIns="0" tIns="12700" rIns="0" bIns="0" rtlCol="0">
             <a:spAutoFit/>
           </a:bodyPr>
           <a:lstStyle/>
@@ -3036,36 +2761,70 @@
           </a:p>
           <a:p>
             <a:pPr algn="l"/>
-            <a:r>
-              <a:rPr sz="400" b="0">
+            <a:endParaRPr sz="1750">
+              <a:latin typeface="Arial MT"/>
+              <a:cs typeface="Arial MT"/>
+            </a:endParaRPr>
+          </a:p>
+          <a:p>
+            <a:pPr algn="l"/>
+            <a:r>
+              <a:rPr sz="1400" b="1">
+                <a:solidFill>
+                  <a:srgbClr val="5C337F"/>
+                </a:solidFill>
+              </a:rPr>
+              <a:t>final_score  =  ( 0.55 × structured_score  +  0.45 × semantic_score )  ×  trust  ×  availability</a:t>
+            </a:r>
+          </a:p>
+          <a:p>
+            <a:pPr algn="l"/>
+            <a:endParaRPr sz="1400" b="1">
+              <a:solidFill>
+                <a:srgbClr val="5C337F"/>
+              </a:solidFill>
+            </a:endParaRPr>
+          </a:p>
+          <a:p>
+            <a:pPr algn="l"/>
+            <a:r>
+              <a:rPr sz="1300" b="1">
+                <a:solidFill>
+                  <a:srgbClr val="16213E"/>
+                </a:solidFill>
+              </a:rPr>
+              <a:t>Structured JD-fit  (scoring.py):</a:t>
+            </a:r>
+          </a:p>
+          <a:p>
+            <a:pPr algn="l"/>
+            <a:r>
+              <a:rPr sz="1200" b="0">
                 <a:solidFill>
                   <a:srgbClr val="1A1A1A"/>
                 </a:solidFill>
               </a:rPr>
-              <a:t/>
-            </a:r>
-          </a:p>
-          <a:p>
-            <a:pPr algn="l"/>
-            <a:r>
-              <a:rPr sz="1400" b="1">
-                <a:solidFill>
-                  <a:srgbClr val="5C337F"/>
-                </a:solidFill>
-              </a:rPr>
-              <a:t>final_score  =  ( 0.55 × structured_score  +  0.45 × semantic_score )  ×  trust  ×  availability</a:t>
-            </a:r>
-          </a:p>
-          <a:p>
-            <a:pPr algn="l"/>
-            <a:r>
-              <a:rPr sz="500" b="0">
+              <a:t>  Title fit  ·  Experience band  ·  4 must-have skill families  ·  Location (Pune/Noida preferred; 9-city acceptable list)  ·  Notice period</a:t>
+            </a:r>
+          </a:p>
+          <a:p>
+            <a:pPr algn="l"/>
+            <a:r>
+              <a:rPr sz="1200" b="0">
                 <a:solidFill>
                   <a:srgbClr val="1A1A1A"/>
                 </a:solidFill>
               </a:rPr>
-              <a:t/>
-            </a:r>
+              <a:t>  Off-target title = multiplicative gate ×0.9 — a Sales Executive with 20 ML skills still scores near 0.</a:t>
+            </a:r>
+          </a:p>
+          <a:p>
+            <a:pPr algn="l"/>
+            <a:endParaRPr sz="1200" b="0">
+              <a:solidFill>
+                <a:srgbClr val="1A1A1A"/>
+              </a:solidFill>
+            </a:endParaRPr>
           </a:p>
           <a:p>
             <a:pPr algn="l"/>
@@ -3075,7 +2834,7 @@
                   <a:srgbClr val="16213E"/>
                 </a:solidFill>
               </a:rPr>
-              <a:t>Structured JD-fit  (scoring.py):</a:t>
+              <a:t>Semantic similarity  (semantic.py):</a:t>
             </a:r>
           </a:p>
           <a:p>
@@ -3086,7 +2845,26 @@
                   <a:srgbClr val="1A1A1A"/>
                 </a:solidFill>
               </a:rPr>
-              <a:t>  Title fit  ·  Experience band  ·  4 must-have skill families  ·  Location (Pune/Noida preferred; 9-city acceptable list)  ·  Notice period</a:t>
+              <a:t>  TF-IDF vectorise career_history prose  →  TruncatedSVD (100 components)  →  cosine similarity with JD profile text  →  normalise to [0,1] using empirical range [0.3, 0.95]</a:t>
+            </a:r>
+          </a:p>
+          <a:p>
+            <a:pPr algn="l"/>
+            <a:endParaRPr sz="1200" b="0">
+              <a:solidFill>
+                <a:srgbClr val="1A1A1A"/>
+              </a:solidFill>
+            </a:endParaRPr>
+          </a:p>
+          <a:p>
+            <a:pPr algn="l"/>
+            <a:r>
+              <a:rPr sz="1300" b="1">
+                <a:solidFill>
+                  <a:srgbClr val="16213E"/>
+                </a:solidFill>
+              </a:rPr>
+              <a:t>Why 55/45 split?</a:t>
             </a:r>
           </a:p>
           <a:p>
@@ -3097,29 +2875,37 @@
                   <a:srgbClr val="1A1A1A"/>
                 </a:solidFill>
               </a:rPr>
-              <a:t>  Off-target title = multiplicative gate ×0.9 — a Sales Executive with 20 ML skills still scores near 0.</a:t>
-            </a:r>
-          </a:p>
-          <a:p>
-            <a:pPr algn="l"/>
-            <a:r>
-              <a:rPr sz="400" b="0">
+              <a:t>  Structured encodes the JD's explicit, non-negotiable rules.  Semantic is the safety net for vocabulary gaps — important, but secondary when explicit rules are present.</a:t>
+            </a:r>
+          </a:p>
+          <a:p>
+            <a:pPr algn="l"/>
+            <a:endParaRPr sz="1200" b="0">
+              <a:solidFill>
+                <a:srgbClr val="1A1A1A"/>
+              </a:solidFill>
+            </a:endParaRPr>
+          </a:p>
+          <a:p>
+            <a:pPr algn="l"/>
+            <a:r>
+              <a:rPr sz="1300" b="1">
+                <a:solidFill>
+                  <a:srgbClr val="16213E"/>
+                </a:solidFill>
+              </a:rPr>
+              <a:t>Why additive blend but multiplicative modifiers?</a:t>
+            </a:r>
+          </a:p>
+          <a:p>
+            <a:pPr algn="l"/>
+            <a:r>
+              <a:rPr sz="1200" b="0">
                 <a:solidFill>
                   <a:srgbClr val="1A1A1A"/>
                 </a:solidFill>
               </a:rPr>
-              <a:t/>
-            </a:r>
-          </a:p>
-          <a:p>
-            <a:pPr algn="l"/>
-            <a:r>
-              <a:rPr sz="1300" b="1">
-                <a:solidFill>
-                  <a:srgbClr val="16213E"/>
-                </a:solidFill>
-              </a:rPr>
-              <a:t>Semantic similarity  (semantic.py):</a:t>
+              <a:t>  Structured + semantic are complementary views of the same 'fit' question → additive.</a:t>
             </a:r>
           </a:p>
           <a:p>
@@ -3130,96 +2916,16 @@
                   <a:srgbClr val="1A1A1A"/>
                 </a:solidFill>
               </a:rPr>
-              <a:t>  TF-IDF vectorise career_history prose  →  TruncatedSVD (100 components)  →  cosine similarity with JD profile text  →  normalise to [0,1] using empirical range [0.3, 0.95]</a:t>
-            </a:r>
-          </a:p>
-          <a:p>
-            <a:pPr algn="l"/>
-            <a:r>
-              <a:rPr sz="400" b="0">
-                <a:solidFill>
-                  <a:srgbClr val="1A1A1A"/>
-                </a:solidFill>
-              </a:rPr>
-              <a:t/>
-            </a:r>
-          </a:p>
-          <a:p>
-            <a:pPr algn="l"/>
-            <a:r>
-              <a:rPr sz="1300" b="1">
-                <a:solidFill>
-                  <a:srgbClr val="16213E"/>
-                </a:solidFill>
-              </a:rPr>
-              <a:t>Why 55/45 split?</a:t>
-            </a:r>
-          </a:p>
-          <a:p>
-            <a:pPr algn="l"/>
-            <a:r>
-              <a:rPr sz="1200" b="0">
-                <a:solidFill>
-                  <a:srgbClr val="1A1A1A"/>
-                </a:solidFill>
-              </a:rPr>
-              <a:t>  Structured encodes the JD's explicit, non-negotiable rules.  Semantic is the safety net for vocabulary gaps — important, but secondary when explicit rules are present.</a:t>
-            </a:r>
-          </a:p>
-          <a:p>
-            <a:pPr algn="l"/>
-            <a:r>
-              <a:rPr sz="400" b="0">
-                <a:solidFill>
-                  <a:srgbClr val="1A1A1A"/>
-                </a:solidFill>
-              </a:rPr>
-              <a:t/>
-            </a:r>
-          </a:p>
-          <a:p>
-            <a:pPr algn="l"/>
-            <a:r>
-              <a:rPr sz="1300" b="1">
-                <a:solidFill>
-                  <a:srgbClr val="16213E"/>
-                </a:solidFill>
-              </a:rPr>
-              <a:t>Why additive blend but multiplicative modifiers?</a:t>
-            </a:r>
-          </a:p>
-          <a:p>
-            <a:pPr algn="l"/>
-            <a:r>
-              <a:rPr sz="1200" b="0">
-                <a:solidFill>
-                  <a:srgbClr val="1A1A1A"/>
-                </a:solidFill>
-              </a:rPr>
-              <a:t>  Structured + semantic are complementary views of the same 'fit' question → additive.</a:t>
-            </a:r>
-          </a:p>
-          <a:p>
-            <a:pPr algn="l"/>
-            <a:r>
-              <a:rPr sz="1200" b="0">
-                <a:solidFill>
-                  <a:srgbClr val="1A1A1A"/>
-                </a:solidFill>
-              </a:rPr>
               <a:t>  Trust + availability discount a fit score; they don't measure fit → multiplicative.  A 0-trust candidate should approach 0, not average to 50%.</a:t>
             </a:r>
           </a:p>
           <a:p>
             <a:pPr algn="l"/>
-            <a:r>
-              <a:rPr sz="400" b="0">
-                <a:solidFill>
-                  <a:srgbClr val="1A1A1A"/>
-                </a:solidFill>
-              </a:rPr>
-              <a:t/>
-            </a:r>
+            <a:endParaRPr sz="1200" b="0">
+              <a:solidFill>
+                <a:srgbClr val="1A1A1A"/>
+              </a:solidFill>
+            </a:endParaRPr>
           </a:p>
           <a:p>
             <a:pPr algn="l"/>
@@ -3261,12 +2967,14 @@
       </p:grpSpPr>
       <p:pic>
         <p:nvPicPr>
-          <p:cNvPr id="2" name="object 2"/>
-          <p:cNvPicPr/>
+          <p:cNvPr id="4" name="Picture 3" descr="image.png"/>
+          <p:cNvPicPr>
+            <a:picLocks noChangeAspect="1"/>
+          </p:cNvPicPr>
           <p:nvPr/>
         </p:nvPicPr>
         <p:blipFill>
-          <a:blip r:embed="rId2" cstate="print"/>
+          <a:blip r:embed="rId2"/>
           <a:stretch>
             <a:fillRect/>
           </a:stretch>
@@ -3297,7 +3005,7 @@
           </a:prstGeom>
         </p:spPr>
         <p:txBody>
-          <a:bodyPr wrap="square" lIns="0" tIns="12700" rIns="0" bIns="0" rtlCol="0" vert="horz">
+          <a:bodyPr vert="horz" wrap="square" lIns="0" tIns="12700" rIns="0" bIns="0" rtlCol="0">
             <a:spAutoFit/>
           </a:bodyPr>
           <a:lstStyle/>
@@ -3325,14 +3033,62 @@
           </a:p>
           <a:p>
             <a:pPr algn="l"/>
-            <a:r>
-              <a:rPr sz="400" b="0">
+            <a:endParaRPr sz="1650">
+              <a:latin typeface="Arial MT"/>
+              <a:cs typeface="Arial MT"/>
+            </a:endParaRPr>
+          </a:p>
+          <a:p>
+            <a:pPr algn="l"/>
+            <a:r>
+              <a:rPr sz="1400" b="1">
+                <a:solidFill>
+                  <a:srgbClr val="16213E"/>
+                </a:solidFill>
+              </a:rPr>
+              <a:t>How ranking decisions are explained:</a:t>
+            </a:r>
+          </a:p>
+          <a:p>
+            <a:pPr algn="l"/>
+            <a:r>
+              <a:rPr sz="1200" b="0">
                 <a:solidFill>
                   <a:srgbClr val="1A1A1A"/>
                 </a:solidFill>
               </a:rPr>
-              <a:t/>
-            </a:r>
+              <a:t>  Deterministic template system — every reasoning string is built from REAL fields from the candidate's profile.  Zero LLM calls.  Hallucination is structurally impossible.</a:t>
+            </a:r>
+          </a:p>
+          <a:p>
+            <a:pPr algn="l"/>
+            <a:r>
+              <a:rPr sz="1200" b="0">
+                <a:solidFill>
+                  <a:srgbClr val="5C337F"/>
+                </a:solidFill>
+              </a:rPr>
+              <a:t>  Example:  "Staff MLE (Salesforce, 8.8y). 'Staff MLE' lines up squarely with the role. Caveat: last active 80d ago."</a:t>
+            </a:r>
+          </a:p>
+          <a:p>
+            <a:pPr algn="l"/>
+            <a:r>
+              <a:rPr sz="1200" b="0">
+                <a:solidFill>
+                  <a:srgbClr val="1A1A1A"/>
+                </a:solidFill>
+              </a:rPr>
+              <a:t>  Bug caught during validation: two independent classifiers produced contradictory output.  Fixed.  0 contradictions in final top 100.</a:t>
+            </a:r>
+          </a:p>
+          <a:p>
+            <a:pPr algn="l"/>
+            <a:endParaRPr sz="1200" b="0">
+              <a:solidFill>
+                <a:srgbClr val="1A1A1A"/>
+              </a:solidFill>
+            </a:endParaRPr>
           </a:p>
           <a:p>
             <a:pPr algn="l"/>
@@ -3342,7 +3098,7 @@
                   <a:srgbClr val="16213E"/>
                 </a:solidFill>
               </a:rPr>
-              <a:t>How ranking decisions are explained:</a:t>
+              <a:t>Suspicious / fabricated profile handling:</a:t>
             </a:r>
           </a:p>
           <a:p>
@@ -3353,7 +3109,7 @@
                   <a:srgbClr val="1A1A1A"/>
                 </a:solidFill>
               </a:rPr>
-              <a:t>  Deterministic template system — every reasoning string is built from REAL fields from the candidate's profile.  Zero LLM calls.  Hallucination is structurally impossible.</a:t>
+              <a:t>  Honeypot hard gate  (honeypot.py):  5 internal-consistency checks.  59 detected.  0 in top 100.</a:t>
             </a:r>
           </a:p>
           <a:p>
@@ -3361,10 +3117,10 @@
             <a:r>
               <a:rPr sz="1200" b="0">
                 <a:solidFill>
-                  <a:srgbClr val="5C337F"/>
-                </a:solidFill>
-              </a:rPr>
-              <a:t>  Example:  "Staff MLE (Salesforce, 8.8y). 'Staff MLE' lines up squarely with the role. Caveat: last active 80d ago."</a:t>
+                  <a:srgbClr val="1A1A1A"/>
+                </a:solidFill>
+              </a:rPr>
+              <a:t>  Keyword-stuffer suppression:  3,029 off-target-title + ≥5 ML-skill profiles.  Max score: 0.0279.  0 in top 100.</a:t>
             </a:r>
           </a:p>
           <a:p>
@@ -3375,74 +3131,16 @@
                   <a:srgbClr val="1A1A1A"/>
                 </a:solidFill>
               </a:rPr>
-              <a:t>  Bug caught during validation: two independent classifiers produced contradictory output.  Fixed.  0 contradictions in final top 100.</a:t>
-            </a:r>
-          </a:p>
-          <a:p>
-            <a:pPr algn="l"/>
-            <a:r>
-              <a:rPr sz="400" b="0">
-                <a:solidFill>
-                  <a:srgbClr val="1A1A1A"/>
-                </a:solidFill>
-              </a:rPr>
-              <a:t/>
-            </a:r>
-          </a:p>
-          <a:p>
-            <a:pPr algn="l"/>
-            <a:r>
-              <a:rPr sz="1400" b="1">
-                <a:solidFill>
-                  <a:srgbClr val="16213E"/>
-                </a:solidFill>
-              </a:rPr>
-              <a:t>Suspicious / fabricated profile handling:</a:t>
-            </a:r>
-          </a:p>
-          <a:p>
-            <a:pPr algn="l"/>
-            <a:r>
-              <a:rPr sz="1200" b="0">
-                <a:solidFill>
-                  <a:srgbClr val="1A1A1A"/>
-                </a:solidFill>
-              </a:rPr>
-              <a:t>  Honeypot hard gate  (honeypot.py):  5 internal-consistency checks.  59 detected.  0 in top 100.</a:t>
-            </a:r>
-          </a:p>
-          <a:p>
-            <a:pPr algn="l"/>
-            <a:r>
-              <a:rPr sz="1200" b="0">
-                <a:solidFill>
-                  <a:srgbClr val="1A1A1A"/>
-                </a:solidFill>
-              </a:rPr>
-              <a:t>  Keyword-stuffer suppression:  3,029 off-target-title + ≥5 ML-skill profiles.  Max score: 0.0279.  0 in top 100.</a:t>
-            </a:r>
-          </a:p>
-          <a:p>
-            <a:pPr algn="l"/>
-            <a:r>
-              <a:rPr sz="1200" b="0">
-                <a:solidFill>
-                  <a:srgbClr val="1A1A1A"/>
-                </a:solidFill>
-              </a:rPr>
               <a:t>  Hallucination spot-check:  15 random top-100 candidates — company, YoE, Python claim, notice period, last-active day verified against raw profile.  0 issues.</a:t>
             </a:r>
           </a:p>
           <a:p>
             <a:pPr algn="l"/>
-            <a:r>
-              <a:rPr sz="400" b="0">
-                <a:solidFill>
-                  <a:srgbClr val="1A1A1A"/>
-                </a:solidFill>
-              </a:rPr>
-              <a:t/>
-            </a:r>
+            <a:endParaRPr sz="1200" b="0">
+              <a:solidFill>
+                <a:srgbClr val="1A1A1A"/>
+              </a:solidFill>
+            </a:endParaRPr>
           </a:p>
           <a:p>
             <a:pPr algn="l"/>
@@ -3560,26 +3258,28 @@
         <p:txBody>
           <a:bodyPr wrap="square" lIns="0" tIns="0" rIns="0" bIns="0" rtlCol="0"/>
           <a:lstStyle/>
-          <a:p/>
-        </p:txBody>
-      </p:sp>
-      <p:sp>
-        <p:nvSpPr>
-          <p:cNvPr id="3" name="object 3"/>
+          <a:p>
+            <a:endParaRPr/>
+          </a:p>
+        </p:txBody>
+      </p:sp>
+      <p:sp>
+        <p:nvSpPr>
+          <p:cNvPr id="5" name="object 5"/>
           <p:cNvSpPr txBox="1"/>
           <p:nvPr/>
         </p:nvSpPr>
         <p:spPr>
           <a:xfrm>
-            <a:off x="-5486400" y="1171447"/>
-            <a:ext cx="835660" cy="254000"/>
+            <a:off x="8343311" y="1145032"/>
+            <a:ext cx="1332865" cy="314960"/>
           </a:xfrm>
           <a:prstGeom prst="rect">
             <a:avLst/>
           </a:prstGeom>
         </p:spPr>
         <p:txBody>
-          <a:bodyPr wrap="square" lIns="0" tIns="12700" rIns="0" bIns="0" rtlCol="0" vert="horz">
+          <a:bodyPr vert="horz" wrap="square" lIns="0" tIns="12700" rIns="0" bIns="0" rtlCol="0">
             <a:spAutoFit/>
           </a:bodyPr>
           <a:lstStyle/>
@@ -3593,139 +3293,7 @@
               </a:spcBef>
             </a:pPr>
             <a:r>
-              <a:rPr dirty="0" sz="1500">
-                <a:solidFill>
-                  <a:srgbClr val="FFFFFF"/>
-                </a:solidFill>
-                <a:latin typeface="Calibri"/>
-                <a:cs typeface="Calibri"/>
-              </a:rPr>
-              <a:t>Ø</a:t>
-            </a:r>
-            <a:r>
-              <a:rPr dirty="0" sz="1500" spc="80">
-                <a:solidFill>
-                  <a:srgbClr val="FFFFFF"/>
-                </a:solidFill>
-                <a:latin typeface="Calibri"/>
-                <a:cs typeface="Calibri"/>
-              </a:rPr>
-              <a:t>  </a:t>
-            </a:r>
-            <a:r>
-              <a:rPr dirty="0" sz="1500" spc="40">
-                <a:solidFill>
-                  <a:srgbClr val="FFFFFF"/>
-                </a:solidFill>
-                <a:latin typeface="Calibri"/>
-                <a:cs typeface="Calibri"/>
-              </a:rPr>
-              <a:t>redrob</a:t>
-            </a:r>
-            <a:endParaRPr sz="1500">
-              <a:latin typeface="Calibri"/>
-              <a:cs typeface="Calibri"/>
-            </a:endParaRPr>
-          </a:p>
-        </p:txBody>
-      </p:sp>
-      <p:sp>
-        <p:nvSpPr>
-          <p:cNvPr id="4" name="object 4"/>
-          <p:cNvSpPr txBox="1"/>
-          <p:nvPr/>
-        </p:nvSpPr>
-        <p:spPr>
-          <a:xfrm>
-            <a:off x="-5486400" y="1171447"/>
-            <a:ext cx="371475" cy="254000"/>
-          </a:xfrm>
-          <a:prstGeom prst="rect">
-            <a:avLst/>
-          </a:prstGeom>
-        </p:spPr>
-        <p:txBody>
-          <a:bodyPr wrap="square" lIns="0" tIns="12700" rIns="0" bIns="0" rtlCol="0" vert="horz">
-            <a:spAutoFit/>
-          </a:bodyPr>
-          <a:lstStyle/>
-          <a:p>
-            <a:pPr marL="12700">
-              <a:lnSpc>
-                <a:spcPct val="100000"/>
-              </a:lnSpc>
-              <a:spcBef>
-                <a:spcPts val="100"/>
-              </a:spcBef>
-            </a:pPr>
-            <a:r>
-              <a:rPr dirty="0" sz="1500">
-                <a:solidFill>
-                  <a:srgbClr val="FFFFFF"/>
-                </a:solidFill>
-                <a:latin typeface="Calibri"/>
-                <a:cs typeface="Calibri"/>
-              </a:rPr>
-              <a:t>i</a:t>
-            </a:r>
-            <a:r>
-              <a:rPr dirty="0" sz="1500" spc="70">
-                <a:solidFill>
-                  <a:srgbClr val="FFFFFF"/>
-                </a:solidFill>
-                <a:latin typeface="Calibri"/>
-                <a:cs typeface="Calibri"/>
-              </a:rPr>
-              <a:t> </a:t>
-            </a:r>
-            <a:r>
-              <a:rPr dirty="0" sz="1500" spc="-25">
-                <a:solidFill>
-                  <a:srgbClr val="FFFFFF"/>
-                </a:solidFill>
-                <a:latin typeface="Calibri"/>
-                <a:cs typeface="Calibri"/>
-              </a:rPr>
-              <a:t>i2S</a:t>
-            </a:r>
-            <a:endParaRPr sz="1500">
-              <a:latin typeface="Calibri"/>
-              <a:cs typeface="Calibri"/>
-            </a:endParaRPr>
-          </a:p>
-        </p:txBody>
-      </p:sp>
-      <p:sp>
-        <p:nvSpPr>
-          <p:cNvPr id="5" name="object 5"/>
-          <p:cNvSpPr txBox="1"/>
-          <p:nvPr/>
-        </p:nvSpPr>
-        <p:spPr>
-          <a:xfrm>
-            <a:off x="8343311" y="1145032"/>
-            <a:ext cx="1332865" cy="314960"/>
-          </a:xfrm>
-          <a:prstGeom prst="rect">
-            <a:avLst/>
-          </a:prstGeom>
-        </p:spPr>
-        <p:txBody>
-          <a:bodyPr wrap="square" lIns="0" tIns="12700" rIns="0" bIns="0" rtlCol="0" vert="horz">
-            <a:spAutoFit/>
-          </a:bodyPr>
-          <a:lstStyle/>
-          <a:p>
-            <a:pPr marL="12700">
-              <a:lnSpc>
-                <a:spcPct val="100000"/>
-              </a:lnSpc>
-              <a:spcBef>
-                <a:spcPts val="100"/>
-              </a:spcBef>
-            </a:pPr>
-            <a:r>
-              <a:rPr dirty="0" sz="1900" spc="-10" i="1">
+              <a:rPr sz="1900" i="1" spc="-10" dirty="0">
                 <a:solidFill>
                   <a:srgbClr val="FFFFFF"/>
                 </a:solidFill>
@@ -3757,7 +3325,7 @@
           </a:prstGeom>
         </p:spPr>
         <p:txBody>
-          <a:bodyPr wrap="square" lIns="0" tIns="12700" rIns="0" bIns="0" rtlCol="0" vert="horz">
+          <a:bodyPr vert="horz" wrap="square" lIns="0" tIns="12700" rIns="0" bIns="0" rtlCol="0">
             <a:spAutoFit/>
           </a:bodyPr>
           <a:lstStyle/>
@@ -3821,7 +3389,7 @@
           </a:fontRef>
         </p:style>
         <p:txBody>
-          <a:bodyPr rtlCol="0" anchor="ctr" wrap="square"/>
+          <a:bodyPr wrap="square" rtlCol="0" anchor="ctr"/>
           <a:lstStyle/>
           <a:p>
             <a:pPr algn="ctr"/>
@@ -3874,7 +3442,7 @@
           </a:fontRef>
         </p:style>
         <p:txBody>
-          <a:bodyPr rtlCol="0" anchor="ctr" wrap="square"/>
+          <a:bodyPr wrap="square" rtlCol="0" anchor="ctr"/>
           <a:lstStyle/>
           <a:p>
             <a:pPr algn="l"/>
@@ -3925,7 +3493,7 @@
           </a:fontRef>
         </p:style>
         <p:txBody>
-          <a:bodyPr rtlCol="0" anchor="ctr" wrap="square"/>
+          <a:bodyPr wrap="square" rtlCol="0" anchor="ctr"/>
           <a:lstStyle/>
           <a:p>
             <a:pPr algn="ctr"/>
@@ -3978,7 +3546,7 @@
           </a:fontRef>
         </p:style>
         <p:txBody>
-          <a:bodyPr rtlCol="0" anchor="ctr" wrap="square"/>
+          <a:bodyPr wrap="square" rtlCol="0" anchor="ctr"/>
           <a:lstStyle/>
           <a:p>
             <a:pPr algn="l"/>
@@ -4029,7 +3597,7 @@
           </a:fontRef>
         </p:style>
         <p:txBody>
-          <a:bodyPr rtlCol="0" anchor="ctr" wrap="square"/>
+          <a:bodyPr wrap="square" rtlCol="0" anchor="ctr"/>
           <a:lstStyle/>
           <a:p>
             <a:pPr algn="ctr"/>
@@ -4082,7 +3650,7 @@
           </a:fontRef>
         </p:style>
         <p:txBody>
-          <a:bodyPr rtlCol="0" anchor="ctr" wrap="square"/>
+          <a:bodyPr wrap="square" rtlCol="0" anchor="ctr"/>
           <a:lstStyle/>
           <a:p>
             <a:pPr algn="l"/>
@@ -4133,7 +3701,7 @@
           </a:fontRef>
         </p:style>
         <p:txBody>
-          <a:bodyPr rtlCol="0" anchor="ctr" wrap="square"/>
+          <a:bodyPr wrap="square" rtlCol="0" anchor="ctr"/>
           <a:lstStyle/>
           <a:p>
             <a:pPr algn="ctr"/>
@@ -4186,7 +3754,7 @@
           </a:fontRef>
         </p:style>
         <p:txBody>
-          <a:bodyPr rtlCol="0" anchor="ctr" wrap="square"/>
+          <a:bodyPr wrap="square" rtlCol="0" anchor="ctr"/>
           <a:lstStyle/>
           <a:p>
             <a:pPr algn="l"/>
@@ -4237,7 +3805,7 @@
           </a:fontRef>
         </p:style>
         <p:txBody>
-          <a:bodyPr rtlCol="0" anchor="ctr" wrap="square"/>
+          <a:bodyPr wrap="square" rtlCol="0" anchor="ctr"/>
           <a:lstStyle/>
           <a:p>
             <a:pPr algn="ctr"/>
@@ -4290,7 +3858,7 @@
           </a:fontRef>
         </p:style>
         <p:txBody>
-          <a:bodyPr rtlCol="0" anchor="ctr" wrap="square"/>
+          <a:bodyPr wrap="square" rtlCol="0" anchor="ctr"/>
           <a:lstStyle/>
           <a:p>
             <a:pPr algn="l"/>
@@ -4341,7 +3909,7 @@
           </a:fontRef>
         </p:style>
         <p:txBody>
-          <a:bodyPr rtlCol="0" anchor="ctr" wrap="square"/>
+          <a:bodyPr wrap="square" rtlCol="0" anchor="ctr"/>
           <a:lstStyle/>
           <a:p>
             <a:pPr algn="ctr"/>
@@ -4394,7 +3962,7 @@
           </a:fontRef>
         </p:style>
         <p:txBody>
-          <a:bodyPr rtlCol="0" anchor="ctr" wrap="square"/>
+          <a:bodyPr wrap="square" rtlCol="0" anchor="ctr"/>
           <a:lstStyle/>
           <a:p>
             <a:pPr algn="l"/>
@@ -4445,7 +4013,7 @@
           </a:fontRef>
         </p:style>
         <p:txBody>
-          <a:bodyPr rtlCol="0" anchor="ctr" wrap="square"/>
+          <a:bodyPr wrap="square" rtlCol="0" anchor="ctr"/>
           <a:lstStyle/>
           <a:p>
             <a:pPr algn="ctr"/>
@@ -4498,7 +4066,7 @@
           </a:fontRef>
         </p:style>
         <p:txBody>
-          <a:bodyPr rtlCol="0" anchor="ctr" wrap="square"/>
+          <a:bodyPr wrap="square" rtlCol="0" anchor="ctr"/>
           <a:lstStyle/>
           <a:p>
             <a:pPr algn="l"/>
@@ -4515,7 +4083,7 @@
       </p:sp>
       <p:pic>
         <p:nvPicPr>
-          <p:cNvPr id="21" name="Picture 20" descr="logos_transparent.png"/>
+          <p:cNvPr id="21" name="Picture 20" descr="logos_clean.png"/>
           <p:cNvPicPr>
             <a:picLocks noChangeAspect="1"/>
           </p:cNvPicPr>
@@ -4529,8 +4097,8 @@
         </p:blipFill>
         <p:spPr>
           <a:xfrm>
-            <a:off x="256032" y="1060704"/>
-            <a:ext cx="1816377" cy="512064"/>
+            <a:off x="256032" y="1049731"/>
+            <a:ext cx="1819656" cy="502920"/>
           </a:xfrm>
           <a:prstGeom prst="rect">
             <a:avLst/>
@@ -4629,138 +4197,8 @@
         <p:txBody>
           <a:bodyPr wrap="square" lIns="0" tIns="0" rIns="0" bIns="0" rtlCol="0"/>
           <a:lstStyle/>
-          <a:p/>
-        </p:txBody>
-      </p:sp>
-      <p:sp>
-        <p:nvSpPr>
-          <p:cNvPr id="4" name="object 4"/>
-          <p:cNvSpPr txBox="1"/>
-          <p:nvPr/>
-        </p:nvSpPr>
-        <p:spPr>
-          <a:xfrm>
-            <a:off x="-5486400" y="1171447"/>
-            <a:ext cx="835660" cy="254000"/>
-          </a:xfrm>
-          <a:prstGeom prst="rect">
-            <a:avLst/>
-          </a:prstGeom>
-        </p:spPr>
-        <p:txBody>
-          <a:bodyPr wrap="square" lIns="0" tIns="12700" rIns="0" bIns="0" rtlCol="0" vert="horz">
-            <a:spAutoFit/>
-          </a:bodyPr>
-          <a:lstStyle/>
-          <a:p>
-            <a:pPr marL="12700">
-              <a:lnSpc>
-                <a:spcPct val="100000"/>
-              </a:lnSpc>
-              <a:spcBef>
-                <a:spcPts val="100"/>
-              </a:spcBef>
-            </a:pPr>
-            <a:r>
-              <a:rPr dirty="0" sz="1500">
-                <a:solidFill>
-                  <a:srgbClr val="FFFFFF"/>
-                </a:solidFill>
-                <a:latin typeface="Calibri"/>
-                <a:cs typeface="Calibri"/>
-              </a:rPr>
-              <a:t>Ø</a:t>
-            </a:r>
-            <a:r>
-              <a:rPr dirty="0" sz="1500" spc="80">
-                <a:solidFill>
-                  <a:srgbClr val="FFFFFF"/>
-                </a:solidFill>
-                <a:latin typeface="Calibri"/>
-                <a:cs typeface="Calibri"/>
-              </a:rPr>
-              <a:t>  </a:t>
-            </a:r>
-            <a:r>
-              <a:rPr dirty="0" sz="1500" spc="40">
-                <a:solidFill>
-                  <a:srgbClr val="FFFFFF"/>
-                </a:solidFill>
-                <a:latin typeface="Calibri"/>
-                <a:cs typeface="Calibri"/>
-              </a:rPr>
-              <a:t>redrob</a:t>
-            </a:r>
-            <a:endParaRPr sz="1500">
-              <a:latin typeface="Calibri"/>
-              <a:cs typeface="Calibri"/>
-            </a:endParaRPr>
-          </a:p>
-        </p:txBody>
-      </p:sp>
-      <p:sp>
-        <p:nvSpPr>
-          <p:cNvPr id="5" name="object 5"/>
-          <p:cNvSpPr txBox="1"/>
-          <p:nvPr/>
-        </p:nvSpPr>
-        <p:spPr>
-          <a:xfrm>
-            <a:off x="-5486400" y="1171447"/>
-            <a:ext cx="371475" cy="254000"/>
-          </a:xfrm>
-          <a:prstGeom prst="rect">
-            <a:avLst/>
-          </a:prstGeom>
-        </p:spPr>
-        <p:txBody>
-          <a:bodyPr wrap="square" lIns="0" tIns="12700" rIns="0" bIns="0" rtlCol="0" vert="horz">
-            <a:spAutoFit/>
-          </a:bodyPr>
-          <a:lstStyle/>
-          <a:p>
-            <a:pPr marL="12700">
-              <a:lnSpc>
-                <a:spcPct val="100000"/>
-              </a:lnSpc>
-              <a:spcBef>
-                <a:spcPts val="100"/>
-              </a:spcBef>
-            </a:pPr>
-            <a:r>
-              <a:rPr dirty="0" sz="1500">
-                <a:solidFill>
-                  <a:srgbClr val="FFFFFF"/>
-                </a:solidFill>
-                <a:latin typeface="Calibri"/>
-                <a:cs typeface="Calibri"/>
-              </a:rPr>
-              <a:t>i</a:t>
-            </a:r>
-            <a:r>
-              <a:rPr dirty="0" sz="1500" spc="70">
-                <a:solidFill>
-                  <a:srgbClr val="FFFFFF"/>
-                </a:solidFill>
-                <a:latin typeface="Calibri"/>
-                <a:cs typeface="Calibri"/>
-              </a:rPr>
-              <a:t> </a:t>
-            </a:r>
-            <a:r>
-              <a:rPr dirty="0" sz="1500" spc="-25">
-                <a:solidFill>
-                  <a:srgbClr val="FFFFFF"/>
-                </a:solidFill>
-                <a:latin typeface="Calibri"/>
-                <a:cs typeface="Calibri"/>
-              </a:rPr>
-              <a:t>i2S</a:t>
-            </a:r>
-            <a:endParaRPr sz="1500">
-              <a:latin typeface="Calibri"/>
-              <a:cs typeface="Calibri"/>
-            </a:endParaRPr>
+          <a:p>
+            <a:endParaRPr/>
           </a:p>
         </p:txBody>
       </p:sp>
@@ -4775,10 +4213,12 @@
           </p:nvPr>
         </p:nvSpPr>
         <p:spPr>
-          <a:prstGeom prst="rect"/>
-        </p:spPr>
-        <p:txBody>
-          <a:bodyPr wrap="square" lIns="0" tIns="12700" rIns="0" bIns="0" rtlCol="0" vert="horz">
+          <a:prstGeom prst="rect">
+            <a:avLst/>
+          </a:prstGeom>
+        </p:spPr>
+        <p:txBody>
+          <a:bodyPr vert="horz" wrap="square" lIns="0" tIns="12700" rIns="0" bIns="0" rtlCol="0">
             <a:spAutoFit/>
           </a:bodyPr>
           <a:lstStyle/>
@@ -4792,7 +4232,7 @@
               </a:spcBef>
             </a:pPr>
             <a:r>
-              <a:rPr dirty="0" sz="1900" spc="-10"/>
+              <a:rPr sz="1900" spc="-10" dirty="0"/>
               <a:t>INDIA.RUNS</a:t>
             </a:r>
             <a:endParaRPr sz="1900"/>
@@ -4815,7 +4255,7 @@
           </a:prstGeom>
         </p:spPr>
         <p:txBody>
-          <a:bodyPr wrap="square" lIns="0" tIns="12700" rIns="0" bIns="0" rtlCol="0" vert="horz">
+          <a:bodyPr vert="horz" wrap="square" lIns="0" tIns="12700" rIns="0" bIns="0" rtlCol="0">
             <a:spAutoFit/>
           </a:bodyPr>
           <a:lstStyle/>
@@ -4879,7 +4319,7 @@
           </a:fontRef>
         </p:style>
         <p:txBody>
-          <a:bodyPr rtlCol="0" anchor="ctr" wrap="square"/>
+          <a:bodyPr wrap="square" rtlCol="0" anchor="ctr"/>
           <a:lstStyle/>
           <a:p>
             <a:pPr algn="ctr"/>
@@ -4964,7 +4404,7 @@
           </a:fontRef>
         </p:style>
         <p:txBody>
-          <a:bodyPr rtlCol="0" anchor="ctr" wrap="square"/>
+          <a:bodyPr wrap="square" rtlCol="0" anchor="ctr"/>
           <a:lstStyle/>
           <a:p>
             <a:pPr algn="ctr"/>
@@ -5084,7 +4524,7 @@
           </a:fontRef>
         </p:style>
         <p:txBody>
-          <a:bodyPr rtlCol="0" anchor="ctr" wrap="square"/>
+          <a:bodyPr wrap="square" rtlCol="0" anchor="ctr"/>
           <a:lstStyle/>
           <a:p>
             <a:pPr algn="ctr"/>
@@ -5137,7 +4577,7 @@
           </a:fontRef>
         </p:style>
         <p:txBody>
-          <a:bodyPr rtlCol="0" anchor="ctr" wrap="square"/>
+          <a:bodyPr wrap="square" rtlCol="0" anchor="ctr"/>
           <a:lstStyle/>
           <a:p>
             <a:pPr algn="ctr"/>
@@ -5259,7 +4699,7 @@
           </a:fontRef>
         </p:style>
         <p:txBody>
-          <a:bodyPr rtlCol="0" anchor="ctr" wrap="square"/>
+          <a:bodyPr wrap="square" rtlCol="0" anchor="ctr"/>
           <a:lstStyle/>
           <a:p>
             <a:pPr algn="ctr"/>
@@ -5344,7 +4784,7 @@
           </a:fontRef>
         </p:style>
         <p:txBody>
-          <a:bodyPr rtlCol="0" anchor="ctr" wrap="square"/>
+          <a:bodyPr wrap="square" rtlCol="0" anchor="ctr"/>
           <a:lstStyle/>
           <a:p>
             <a:pPr algn="ctr"/>
@@ -5464,7 +4904,7 @@
           </a:fontRef>
         </p:style>
         <p:txBody>
-          <a:bodyPr rtlCol="0" anchor="ctr" wrap="square"/>
+          <a:bodyPr wrap="square" rtlCol="0" anchor="ctr"/>
           <a:lstStyle/>
           <a:p>
             <a:pPr algn="ctr"/>
@@ -5549,7 +4989,7 @@
           </a:fontRef>
         </p:style>
         <p:txBody>
-          <a:bodyPr rtlCol="0" anchor="ctr" wrap="square"/>
+          <a:bodyPr wrap="square" rtlCol="0" anchor="ctr"/>
           <a:lstStyle/>
           <a:p>
             <a:pPr algn="ctr"/>
@@ -5634,7 +5074,7 @@
           </a:fontRef>
         </p:style>
         <p:txBody>
-          <a:bodyPr rtlCol="0" anchor="ctr" wrap="square"/>
+          <a:bodyPr wrap="square" rtlCol="0" anchor="ctr"/>
           <a:lstStyle/>
           <a:p>
             <a:pPr algn="ctr"/>
@@ -5685,7 +5125,7 @@
       </p:sp>
       <p:pic>
         <p:nvPicPr>
-          <p:cNvPr id="28" name="Picture 27" descr="logos_transparent.png"/>
+          <p:cNvPr id="28" name="Picture 27" descr="logos_clean.png"/>
           <p:cNvPicPr>
             <a:picLocks noChangeAspect="1"/>
           </p:cNvPicPr>
@@ -5699,8 +5139,8 @@
         </p:blipFill>
         <p:spPr>
           <a:xfrm>
-            <a:off x="256032" y="1060704"/>
-            <a:ext cx="1816377" cy="512064"/>
+            <a:off x="256032" y="1049731"/>
+            <a:ext cx="1819656" cy="502920"/>
           </a:xfrm>
           <a:prstGeom prst="rect">
             <a:avLst/>
@@ -5777,26 +5217,28 @@
         <p:txBody>
           <a:bodyPr wrap="square" lIns="0" tIns="0" rIns="0" bIns="0" rtlCol="0"/>
           <a:lstStyle/>
-          <a:p/>
-        </p:txBody>
-      </p:sp>
-      <p:sp>
-        <p:nvSpPr>
-          <p:cNvPr id="3" name="object 3"/>
+          <a:p>
+            <a:endParaRPr/>
+          </a:p>
+        </p:txBody>
+      </p:sp>
+      <p:sp>
+        <p:nvSpPr>
+          <p:cNvPr id="5" name="object 5"/>
           <p:cNvSpPr txBox="1"/>
           <p:nvPr/>
         </p:nvSpPr>
         <p:spPr>
           <a:xfrm>
-            <a:off x="-5486400" y="1171447"/>
-            <a:ext cx="835660" cy="254000"/>
+            <a:off x="8343311" y="1145032"/>
+            <a:ext cx="1332865" cy="314960"/>
           </a:xfrm>
           <a:prstGeom prst="rect">
             <a:avLst/>
           </a:prstGeom>
         </p:spPr>
         <p:txBody>
-          <a:bodyPr wrap="square" lIns="0" tIns="12700" rIns="0" bIns="0" rtlCol="0" vert="horz">
+          <a:bodyPr vert="horz" wrap="square" lIns="0" tIns="12700" rIns="0" bIns="0" rtlCol="0">
             <a:spAutoFit/>
           </a:bodyPr>
           <a:lstStyle/>
@@ -5810,139 +5252,7 @@
               </a:spcBef>
             </a:pPr>
             <a:r>
-              <a:rPr dirty="0" sz="1500">
-                <a:solidFill>
-                  <a:srgbClr val="FFFFFF"/>
-                </a:solidFill>
-                <a:latin typeface="Calibri"/>
-                <a:cs typeface="Calibri"/>
-              </a:rPr>
-              <a:t>Ø</a:t>
-            </a:r>
-            <a:r>
-              <a:rPr dirty="0" sz="1500" spc="80">
-                <a:solidFill>
-                  <a:srgbClr val="FFFFFF"/>
-                </a:solidFill>
-                <a:latin typeface="Calibri"/>
-                <a:cs typeface="Calibri"/>
-              </a:rPr>
-              <a:t>  </a:t>
-            </a:r>
-            <a:r>
-              <a:rPr dirty="0" sz="1500" spc="40">
-                <a:solidFill>
-                  <a:srgbClr val="FFFFFF"/>
-                </a:solidFill>
-                <a:latin typeface="Calibri"/>
-                <a:cs typeface="Calibri"/>
-              </a:rPr>
-              <a:t>redrob</a:t>
-            </a:r>
-            <a:endParaRPr sz="1500">
-              <a:latin typeface="Calibri"/>
-              <a:cs typeface="Calibri"/>
-            </a:endParaRPr>
-          </a:p>
-        </p:txBody>
-      </p:sp>
-      <p:sp>
-        <p:nvSpPr>
-          <p:cNvPr id="4" name="object 4"/>
-          <p:cNvSpPr txBox="1"/>
-          <p:nvPr/>
-        </p:nvSpPr>
-        <p:spPr>
-          <a:xfrm>
-            <a:off x="-5486400" y="1171447"/>
-            <a:ext cx="371475" cy="254000"/>
-          </a:xfrm>
-          <a:prstGeom prst="rect">
-            <a:avLst/>
-          </a:prstGeom>
-        </p:spPr>
-        <p:txBody>
-          <a:bodyPr wrap="square" lIns="0" tIns="12700" rIns="0" bIns="0" rtlCol="0" vert="horz">
-            <a:spAutoFit/>
-          </a:bodyPr>
-          <a:lstStyle/>
-          <a:p>
-            <a:pPr marL="12700">
-              <a:lnSpc>
-                <a:spcPct val="100000"/>
-              </a:lnSpc>
-              <a:spcBef>
-                <a:spcPts val="100"/>
-              </a:spcBef>
-            </a:pPr>
-            <a:r>
-              <a:rPr dirty="0" sz="1500">
-                <a:solidFill>
-                  <a:srgbClr val="FFFFFF"/>
-                </a:solidFill>
-                <a:latin typeface="Calibri"/>
-                <a:cs typeface="Calibri"/>
-              </a:rPr>
-              <a:t>i</a:t>
-            </a:r>
-            <a:r>
-              <a:rPr dirty="0" sz="1500" spc="70">
-                <a:solidFill>
-                  <a:srgbClr val="FFFFFF"/>
-                </a:solidFill>
-                <a:latin typeface="Calibri"/>
-                <a:cs typeface="Calibri"/>
-              </a:rPr>
-              <a:t> </a:t>
-            </a:r>
-            <a:r>
-              <a:rPr dirty="0" sz="1500" spc="-25">
-                <a:solidFill>
-                  <a:srgbClr val="FFFFFF"/>
-                </a:solidFill>
-                <a:latin typeface="Calibri"/>
-                <a:cs typeface="Calibri"/>
-              </a:rPr>
-              <a:t>i2S</a:t>
-            </a:r>
-            <a:endParaRPr sz="1500">
-              <a:latin typeface="Calibri"/>
-              <a:cs typeface="Calibri"/>
-            </a:endParaRPr>
-          </a:p>
-        </p:txBody>
-      </p:sp>
-      <p:sp>
-        <p:nvSpPr>
-          <p:cNvPr id="5" name="object 5"/>
-          <p:cNvSpPr txBox="1"/>
-          <p:nvPr/>
-        </p:nvSpPr>
-        <p:spPr>
-          <a:xfrm>
-            <a:off x="8343311" y="1145032"/>
-            <a:ext cx="1332865" cy="314960"/>
-          </a:xfrm>
-          <a:prstGeom prst="rect">
-            <a:avLst/>
-          </a:prstGeom>
-        </p:spPr>
-        <p:txBody>
-          <a:bodyPr wrap="square" lIns="0" tIns="12700" rIns="0" bIns="0" rtlCol="0" vert="horz">
-            <a:spAutoFit/>
-          </a:bodyPr>
-          <a:lstStyle/>
-          <a:p>
-            <a:pPr marL="12700">
-              <a:lnSpc>
-                <a:spcPct val="100000"/>
-              </a:lnSpc>
-              <a:spcBef>
-                <a:spcPts val="100"/>
-              </a:spcBef>
-            </a:pPr>
-            <a:r>
-              <a:rPr dirty="0" sz="1900" spc="-10" i="1">
+              <a:rPr sz="1900" i="1" spc="-10" dirty="0">
                 <a:solidFill>
                   <a:srgbClr val="FFFFFF"/>
                 </a:solidFill>
@@ -5974,7 +5284,7 @@
           </a:prstGeom>
         </p:spPr>
         <p:txBody>
-          <a:bodyPr wrap="square" lIns="0" tIns="12700" rIns="0" bIns="0" rtlCol="0" vert="horz">
+          <a:bodyPr vert="horz" wrap="square" lIns="0" tIns="12700" rIns="0" bIns="0" rtlCol="0">
             <a:spAutoFit/>
           </a:bodyPr>
           <a:lstStyle/>
@@ -6002,14 +5312,161 @@
           </a:p>
           <a:p>
             <a:pPr algn="l"/>
-            <a:r>
-              <a:rPr sz="300" b="0">
+            <a:endParaRPr sz="1750">
+              <a:latin typeface="Calibri"/>
+              <a:cs typeface="Calibri"/>
+            </a:endParaRPr>
+          </a:p>
+          <a:p>
+            <a:pPr algn="l"/>
+            <a:r>
+              <a:rPr sz="1300" b="1">
+                <a:solidFill>
+                  <a:srgbClr val="16213E"/>
+                </a:solidFill>
+              </a:rPr>
+              <a:t>Ranking quality:</a:t>
+            </a:r>
+          </a:p>
+          <a:p>
+            <a:pPr algn="l"/>
+            <a:r>
+              <a:rPr sz="1100" b="0">
                 <a:solidFill>
                   <a:srgbClr val="1A1A1A"/>
                 </a:solidFill>
               </a:rPr>
-              <a:t/>
-            </a:r>
+              <a:t>  Gold candidates (8 profiles) in top 100</a:t>
+            </a:r>
+          </a:p>
+          <a:p>
+            <a:pPr algn="l"/>
+            <a:r>
+              <a:rPr sz="1100" b="1">
+                <a:solidFill>
+                  <a:srgbClr val="00854A"/>
+                </a:solidFill>
+              </a:rPr>
+              <a:t>     → 7 / 8  ·  best rank #3  (Senior AI Engineer, Adobe, score 0.9275)</a:t>
+            </a:r>
+          </a:p>
+          <a:p>
+            <a:pPr algn="l"/>
+            <a:r>
+              <a:rPr sz="1100" b="0">
+                <a:solidFill>
+                  <a:srgbClr val="1A1A1A"/>
+                </a:solidFill>
+              </a:rPr>
+              <a:t>  8th gold at rank #175</a:t>
+            </a:r>
+          </a:p>
+          <a:p>
+            <a:pPr algn="l"/>
+            <a:r>
+              <a:rPr sz="1100" b="1">
+                <a:solidFill>
+                  <a:srgbClr val="00854A"/>
+                </a:solidFill>
+              </a:rPr>
+              <a:t>     → Explainable: 93-day inactivity → availability 0.70×  ·  Pure JD-fit rank was #124</a:t>
+            </a:r>
+          </a:p>
+          <a:p>
+            <a:pPr algn="l"/>
+            <a:r>
+              <a:rPr sz="1100" b="0">
+                <a:solidFill>
+                  <a:srgbClr val="1A1A1A"/>
+                </a:solidFill>
+              </a:rPr>
+              <a:t>  Keyword-stuffers (3,029 profiles) in top 100</a:t>
+            </a:r>
+          </a:p>
+          <a:p>
+            <a:pPr algn="l"/>
+            <a:r>
+              <a:rPr sz="1100" b="1">
+                <a:solidFill>
+                  <a:srgbClr val="00854A"/>
+                </a:solidFill>
+              </a:rPr>
+              <a:t>     → 0  ·  Max score: 0.0279  ·  0 above threshold 0.08</a:t>
+            </a:r>
+          </a:p>
+          <a:p>
+            <a:pPr algn="l"/>
+            <a:r>
+              <a:rPr sz="1100" b="0">
+                <a:solidFill>
+                  <a:srgbClr val="1A1A1A"/>
+                </a:solidFill>
+              </a:rPr>
+              <a:t>  Honeypots in top 100</a:t>
+            </a:r>
+          </a:p>
+          <a:p>
+            <a:pPr algn="l"/>
+            <a:r>
+              <a:rPr sz="1100" b="1">
+                <a:solidFill>
+                  <a:srgbClr val="00854A"/>
+                </a:solidFill>
+              </a:rPr>
+              <a:t>     → 0  ·  59 detected total</a:t>
+            </a:r>
+          </a:p>
+          <a:p>
+            <a:pPr algn="l"/>
+            <a:r>
+              <a:rPr sz="1100" b="0">
+                <a:solidFill>
+                  <a:srgbClr val="1A1A1A"/>
+                </a:solidFill>
+              </a:rPr>
+              <a:t>  Reasoning contradictions</a:t>
+            </a:r>
+          </a:p>
+          <a:p>
+            <a:pPr algn="l"/>
+            <a:r>
+              <a:rPr sz="1100" b="1">
+                <a:solidFill>
+                  <a:srgbClr val="00854A"/>
+                </a:solidFill>
+              </a:rPr>
+              <a:t>     → 0  (1 confirmed pre-fix, 0 post-fix)  ·  Hallucination issues: 0</a:t>
+            </a:r>
+          </a:p>
+          <a:p>
+            <a:pPr algn="l"/>
+            <a:r>
+              <a:rPr sz="1100" b="0">
+                <a:solidFill>
+                  <a:srgbClr val="1A1A1A"/>
+                </a:solidFill>
+              </a:rPr>
+              <a:t>  vs. sample submission</a:t>
+            </a:r>
+          </a:p>
+          <a:p>
+            <a:pPr algn="l"/>
+            <a:r>
+              <a:rPr sz="1100" b="1">
+                <a:solidFill>
+                  <a:srgbClr val="00854A"/>
+                </a:solidFill>
+              </a:rPr>
+              <a:t>     → 92/100 of their top 100 = off-target titles.  Ours: 0.</a:t>
+            </a:r>
+          </a:p>
+          <a:p>
+            <a:pPr algn="l"/>
+            <a:endParaRPr sz="1100" b="1">
+              <a:solidFill>
+                <a:srgbClr val="00854A"/>
+              </a:solidFill>
+            </a:endParaRPr>
           </a:p>
           <a:p>
             <a:pPr algn="l"/>
@@ -6019,18 +5476,7 @@
                   <a:srgbClr val="16213E"/>
                 </a:solidFill>
               </a:rPr>
-              <a:t>Ranking quality:</a:t>
-            </a:r>
-          </a:p>
-          <a:p>
-            <a:pPr algn="l"/>
-            <a:r>
-              <a:rPr sz="1100" b="0">
-                <a:solidFill>
-                  <a:srgbClr val="1A1A1A"/>
-                </a:solidFill>
-              </a:rPr>
-              <a:t>  Gold candidates (8 profiles) in top 100</a:t>
+              <a:t>Runtime  (Intel Core 5 210H · 8-core · 16 GB · CPU only):</a:t>
             </a:r>
           </a:p>
           <a:p>
@@ -6041,162 +5487,16 @@
                   <a:srgbClr val="00854A"/>
                 </a:solidFill>
               </a:rPr>
-              <a:t>     → 7 / 8  ·  best rank #3  (Senior AI Engineer, Adobe, score 0.9275)</a:t>
-            </a:r>
-          </a:p>
-          <a:p>
-            <a:pPr algn="l"/>
-            <a:r>
-              <a:rPr sz="1100" b="0">
-                <a:solidFill>
-                  <a:srgbClr val="1A1A1A"/>
-                </a:solidFill>
-              </a:rPr>
-              <a:t>  8th gold at rank #175</a:t>
-            </a:r>
-          </a:p>
-          <a:p>
-            <a:pPr algn="l"/>
-            <a:r>
-              <a:rPr sz="1100" b="1">
-                <a:solidFill>
-                  <a:srgbClr val="00854A"/>
-                </a:solidFill>
-              </a:rPr>
-              <a:t>     → Explainable: 93-day inactivity → availability 0.70×  ·  Pure JD-fit rank was #124</a:t>
-            </a:r>
-          </a:p>
-          <a:p>
-            <a:pPr algn="l"/>
-            <a:r>
-              <a:rPr sz="1100" b="0">
-                <a:solidFill>
-                  <a:srgbClr val="1A1A1A"/>
-                </a:solidFill>
-              </a:rPr>
-              <a:t>  Keyword-stuffers (3,029 profiles) in top 100</a:t>
-            </a:r>
-          </a:p>
-          <a:p>
-            <a:pPr algn="l"/>
-            <a:r>
-              <a:rPr sz="1100" b="1">
-                <a:solidFill>
-                  <a:srgbClr val="00854A"/>
-                </a:solidFill>
-              </a:rPr>
-              <a:t>     → 0  ·  Max score: 0.0279  ·  0 above threshold 0.08</a:t>
-            </a:r>
-          </a:p>
-          <a:p>
-            <a:pPr algn="l"/>
-            <a:r>
-              <a:rPr sz="1100" b="0">
-                <a:solidFill>
-                  <a:srgbClr val="1A1A1A"/>
-                </a:solidFill>
-              </a:rPr>
-              <a:t>  Honeypots in top 100</a:t>
-            </a:r>
-          </a:p>
-          <a:p>
-            <a:pPr algn="l"/>
-            <a:r>
-              <a:rPr sz="1100" b="1">
-                <a:solidFill>
-                  <a:srgbClr val="00854A"/>
-                </a:solidFill>
-              </a:rPr>
-              <a:t>     → 0  ·  59 detected total</a:t>
-            </a:r>
-          </a:p>
-          <a:p>
-            <a:pPr algn="l"/>
-            <a:r>
-              <a:rPr sz="1100" b="0">
-                <a:solidFill>
-                  <a:srgbClr val="1A1A1A"/>
-                </a:solidFill>
-              </a:rPr>
-              <a:t>  Reasoning contradictions</a:t>
-            </a:r>
-          </a:p>
-          <a:p>
-            <a:pPr algn="l"/>
-            <a:r>
-              <a:rPr sz="1100" b="1">
-                <a:solidFill>
-                  <a:srgbClr val="00854A"/>
-                </a:solidFill>
-              </a:rPr>
-              <a:t>     → 0  (1 confirmed pre-fix, 0 post-fix)  ·  Hallucination issues: 0</a:t>
-            </a:r>
-          </a:p>
-          <a:p>
-            <a:pPr algn="l"/>
-            <a:r>
-              <a:rPr sz="1100" b="0">
-                <a:solidFill>
-                  <a:srgbClr val="1A1A1A"/>
-                </a:solidFill>
-              </a:rPr>
-              <a:t>  vs. sample submission</a:t>
-            </a:r>
-          </a:p>
-          <a:p>
-            <a:pPr algn="l"/>
-            <a:r>
-              <a:rPr sz="1100" b="1">
-                <a:solidFill>
-                  <a:srgbClr val="00854A"/>
-                </a:solidFill>
-              </a:rPr>
-              <a:t>     → 92/100 of their top 100 = off-target titles.  Ours: 0.</a:t>
-            </a:r>
-          </a:p>
-          <a:p>
-            <a:pPr algn="l"/>
-            <a:r>
-              <a:rPr sz="300" b="0">
-                <a:solidFill>
-                  <a:srgbClr val="1A1A1A"/>
-                </a:solidFill>
-              </a:rPr>
-              <a:t/>
-            </a:r>
-          </a:p>
-          <a:p>
-            <a:pPr algn="l"/>
-            <a:r>
-              <a:rPr sz="1300" b="1">
-                <a:solidFill>
-                  <a:srgbClr val="16213E"/>
-                </a:solidFill>
-              </a:rPr>
-              <a:t>Runtime  (Intel Core 5 210H · 8-core · 16 GB · CPU only):</a:t>
-            </a:r>
-          </a:p>
-          <a:p>
-            <a:pPr algn="l"/>
-            <a:r>
-              <a:rPr sz="1100" b="1">
-                <a:solidFill>
-                  <a:srgbClr val="00854A"/>
-                </a:solidFill>
-              </a:rPr>
               <a:t>  Load 4.3s  +  Semantic index 39.1s  +  Score 100K 17.3s  +  Reasoning 0.006s  =  61.8s  ·  Budget 300s  ·  Headroom 79%</a:t>
             </a:r>
           </a:p>
           <a:p>
             <a:pPr algn="l"/>
-            <a:r>
-              <a:rPr sz="300" b="0">
-                <a:solidFill>
-                  <a:srgbClr val="1A1A1A"/>
-                </a:solidFill>
-              </a:rPr>
-              <a:t/>
-            </a:r>
+            <a:endParaRPr sz="1100" b="1">
+              <a:solidFill>
+                <a:srgbClr val="00854A"/>
+              </a:solidFill>
+            </a:endParaRPr>
           </a:p>
           <a:p>
             <a:pPr algn="l"/>
@@ -6246,7 +5546,7 @@
       </p:sp>
       <p:pic>
         <p:nvPicPr>
-          <p:cNvPr id="7" name="Picture 6" descr="logos_transparent.png"/>
+          <p:cNvPr id="7" name="Picture 6" descr="logos_clean.png"/>
           <p:cNvPicPr>
             <a:picLocks noChangeAspect="1"/>
           </p:cNvPicPr>
@@ -6260,8 +5560,8 @@
         </p:blipFill>
         <p:spPr>
           <a:xfrm>
-            <a:off x="256032" y="1060704"/>
-            <a:ext cx="1816377" cy="512064"/>
+            <a:off x="256032" y="1049731"/>
+            <a:ext cx="1819656" cy="502920"/>
           </a:xfrm>
           <a:prstGeom prst="rect">
             <a:avLst/>
@@ -6360,138 +5660,8 @@
         <p:txBody>
           <a:bodyPr wrap="square" lIns="0" tIns="0" rIns="0" bIns="0" rtlCol="0"/>
           <a:lstStyle/>
-          <a:p/>
-        </p:txBody>
-      </p:sp>
-      <p:sp>
-        <p:nvSpPr>
-          <p:cNvPr id="4" name="object 4"/>
-          <p:cNvSpPr txBox="1"/>
-          <p:nvPr/>
-        </p:nvSpPr>
-        <p:spPr>
-          <a:xfrm>
-            <a:off x="-5486400" y="1171447"/>
-            <a:ext cx="835660" cy="254000"/>
-          </a:xfrm>
-          <a:prstGeom prst="rect">
-            <a:avLst/>
-          </a:prstGeom>
-        </p:spPr>
-        <p:txBody>
-          <a:bodyPr wrap="square" lIns="0" tIns="12700" rIns="0" bIns="0" rtlCol="0" vert="horz">
-            <a:spAutoFit/>
-          </a:bodyPr>
-          <a:lstStyle/>
-          <a:p>
-            <a:pPr marL="12700">
-              <a:lnSpc>
-                <a:spcPct val="100000"/>
-              </a:lnSpc>
-              <a:spcBef>
-                <a:spcPts val="100"/>
-              </a:spcBef>
-            </a:pPr>
-            <a:r>
-              <a:rPr dirty="0" sz="1500">
-                <a:solidFill>
-                  <a:srgbClr val="FFFFFF"/>
-                </a:solidFill>
-                <a:latin typeface="Calibri"/>
-                <a:cs typeface="Calibri"/>
-              </a:rPr>
-              <a:t>Ø</a:t>
-            </a:r>
-            <a:r>
-              <a:rPr dirty="0" sz="1500" spc="80">
-                <a:solidFill>
-                  <a:srgbClr val="FFFFFF"/>
-                </a:solidFill>
-                <a:latin typeface="Calibri"/>
-                <a:cs typeface="Calibri"/>
-              </a:rPr>
-              <a:t>  </a:t>
-            </a:r>
-            <a:r>
-              <a:rPr dirty="0" sz="1500" spc="40">
-                <a:solidFill>
-                  <a:srgbClr val="FFFFFF"/>
-                </a:solidFill>
-                <a:latin typeface="Calibri"/>
-                <a:cs typeface="Calibri"/>
-              </a:rPr>
-              <a:t>redrob</a:t>
-            </a:r>
-            <a:endParaRPr sz="1500">
-              <a:latin typeface="Calibri"/>
-              <a:cs typeface="Calibri"/>
-            </a:endParaRPr>
-          </a:p>
-        </p:txBody>
-      </p:sp>
-      <p:sp>
-        <p:nvSpPr>
-          <p:cNvPr id="5" name="object 5"/>
-          <p:cNvSpPr txBox="1"/>
-          <p:nvPr/>
-        </p:nvSpPr>
-        <p:spPr>
-          <a:xfrm>
-            <a:off x="-5486400" y="1171447"/>
-            <a:ext cx="371475" cy="254000"/>
-          </a:xfrm>
-          <a:prstGeom prst="rect">
-            <a:avLst/>
-          </a:prstGeom>
-        </p:spPr>
-        <p:txBody>
-          <a:bodyPr wrap="square" lIns="0" tIns="12700" rIns="0" bIns="0" rtlCol="0" vert="horz">
-            <a:spAutoFit/>
-          </a:bodyPr>
-          <a:lstStyle/>
-          <a:p>
-            <a:pPr marL="12700">
-              <a:lnSpc>
-                <a:spcPct val="100000"/>
-              </a:lnSpc>
-              <a:spcBef>
-                <a:spcPts val="100"/>
-              </a:spcBef>
-            </a:pPr>
-            <a:r>
-              <a:rPr dirty="0" sz="1500">
-                <a:solidFill>
-                  <a:srgbClr val="FFFFFF"/>
-                </a:solidFill>
-                <a:latin typeface="Calibri"/>
-                <a:cs typeface="Calibri"/>
-              </a:rPr>
-              <a:t>i</a:t>
-            </a:r>
-            <a:r>
-              <a:rPr dirty="0" sz="1500" spc="70">
-                <a:solidFill>
-                  <a:srgbClr val="FFFFFF"/>
-                </a:solidFill>
-                <a:latin typeface="Calibri"/>
-                <a:cs typeface="Calibri"/>
-              </a:rPr>
-              <a:t> </a:t>
-            </a:r>
-            <a:r>
-              <a:rPr dirty="0" sz="1500" spc="-25">
-                <a:solidFill>
-                  <a:srgbClr val="FFFFFF"/>
-                </a:solidFill>
-                <a:latin typeface="Calibri"/>
-                <a:cs typeface="Calibri"/>
-              </a:rPr>
-              <a:t>i2S</a:t>
-            </a:r>
-            <a:endParaRPr sz="1500">
-              <a:latin typeface="Calibri"/>
-              <a:cs typeface="Calibri"/>
-            </a:endParaRPr>
+          <a:p>
+            <a:endParaRPr/>
           </a:p>
         </p:txBody>
       </p:sp>
@@ -6506,10 +5676,12 @@
           </p:nvPr>
         </p:nvSpPr>
         <p:spPr>
-          <a:prstGeom prst="rect"/>
-        </p:spPr>
-        <p:txBody>
-          <a:bodyPr wrap="square" lIns="0" tIns="12700" rIns="0" bIns="0" rtlCol="0" vert="horz">
+          <a:prstGeom prst="rect">
+            <a:avLst/>
+          </a:prstGeom>
+        </p:spPr>
+        <p:txBody>
+          <a:bodyPr vert="horz" wrap="square" lIns="0" tIns="12700" rIns="0" bIns="0" rtlCol="0">
             <a:spAutoFit/>
           </a:bodyPr>
           <a:lstStyle/>
@@ -6523,7 +5695,7 @@
               </a:spcBef>
             </a:pPr>
             <a:r>
-              <a:rPr dirty="0" sz="1900" spc="-10"/>
+              <a:rPr sz="1900" spc="-10" dirty="0"/>
               <a:t>INDIA.RUNS</a:t>
             </a:r>
             <a:endParaRPr sz="1900"/>
@@ -6546,7 +5718,7 @@
           </a:prstGeom>
         </p:spPr>
         <p:txBody>
-          <a:bodyPr wrap="square" lIns="0" tIns="12700" rIns="0" bIns="0" rtlCol="0" vert="horz">
+          <a:bodyPr vert="horz" wrap="square" lIns="0" tIns="12700" rIns="0" bIns="0" rtlCol="0">
             <a:spAutoFit/>
           </a:bodyPr>
           <a:lstStyle/>
@@ -6574,35 +5746,42 @@
           </a:p>
           <a:p>
             <a:pPr algn="l"/>
-            <a:r>
-              <a:rPr sz="400" b="0">
+            <a:endParaRPr sz="1650">
+              <a:latin typeface="Arial MT"/>
+              <a:cs typeface="Arial MT"/>
+            </a:endParaRPr>
+          </a:p>
+          <a:p>
+            <a:pPr algn="l"/>
+            <a:r>
+              <a:rPr sz="1200" b="1">
+                <a:solidFill>
+                  <a:srgbClr val="16213E"/>
+                </a:solidFill>
+              </a:rPr>
+              <a:t>Technology              Role                          Why selected</a:t>
+            </a:r>
+          </a:p>
+          <a:p>
+            <a:pPr algn="l"/>
+            <a:r>
+              <a:rPr sz="900" b="0">
+                <a:solidFill>
+                  <a:srgbClr val="BBBBBB"/>
+                </a:solidFill>
+              </a:rPr>
+              <a:t>─────────────────────────────────────────────────────────────────────────────────────</a:t>
+            </a:r>
+          </a:p>
+          <a:p>
+            <a:pPr algn="l"/>
+            <a:r>
+              <a:rPr sz="1200" b="0">
                 <a:solidFill>
                   <a:srgbClr val="1A1A1A"/>
                 </a:solidFill>
               </a:rPr>
-              <a:t/>
-            </a:r>
-          </a:p>
-          <a:p>
-            <a:pPr algn="l"/>
-            <a:r>
-              <a:rPr sz="1200" b="1">
-                <a:solidFill>
-                  <a:srgbClr val="16213E"/>
-                </a:solidFill>
-              </a:rPr>
-              <a:t>Technology              Role                          Why selected</a:t>
-            </a:r>
-          </a:p>
-          <a:p>
-            <a:pPr algn="l"/>
-            <a:r>
-              <a:rPr sz="900" b="0">
-                <a:solidFill>
-                  <a:srgbClr val="BBBBBB"/>
-                </a:solidFill>
-              </a:rPr>
-              <a:t>─────────────────────────────────────────────────────────────────────────────────────</a:t>
+              <a:t>  Python 3.11             Core language                 Standard; maximum cross-environment compatibility</a:t>
             </a:r>
           </a:p>
           <a:p>
@@ -6613,7 +5792,7 @@
                   <a:srgbClr val="1A1A1A"/>
                 </a:solidFill>
               </a:rPr>
-              <a:t>  Python 3.11             Core language                 Standard; maximum cross-environment compatibility</a:t>
+              <a:t>  scikit-learn            TF-IDF + TruncatedSVD         Fully offline; no model downloads; entire semantic layer in one library</a:t>
             </a:r>
           </a:p>
           <a:p>
@@ -6624,7 +5803,7 @@
                   <a:srgbClr val="1A1A1A"/>
                 </a:solidFill>
               </a:rPr>
-              <a:t>  scikit-learn            TF-IDF + TruncatedSVD         Fully offline; no model downloads; entire semantic layer in one library</a:t>
+              <a:t>  numpy                   Vector operations             Required by scikit-learn; no additional footprint</a:t>
             </a:r>
           </a:p>
           <a:p>
@@ -6635,7 +5814,7 @@
                   <a:srgbClr val="1A1A1A"/>
                 </a:solidFill>
               </a:rPr>
-              <a:t>  numpy                   Vector operations             Required by scikit-learn; no additional footprint</a:t>
+              <a:t>  Gradio 5                HF Spaces demo UI             Free cpu-basic tier; queue protocol for concurrent users</a:t>
             </a:r>
           </a:p>
           <a:p>
@@ -6646,7 +5825,7 @@
                   <a:srgbClr val="1A1A1A"/>
                 </a:solidFill>
               </a:rPr>
-              <a:t>  Gradio 5                HF Spaces demo UI             Free cpu-basic tier; queue protocol for concurrent users</a:t>
+              <a:t>  HuggingFace Spaces      Live sandbox demo             Free public URL; no infra setup; live at Suriya-25/redrob-ranker</a:t>
             </a:r>
           </a:p>
           <a:p>
@@ -6657,7 +5836,7 @@
                   <a:srgbClr val="1A1A1A"/>
                 </a:solidFill>
               </a:rPr>
-              <a:t>  HuggingFace Spaces      Live sandbox demo             Free public URL; no infra setup; live at Suriya-25/redrob-ranker</a:t>
+              <a:t>  python-pptx             Deck generation               Builds directly into organizer's .pptx preserving branding</a:t>
             </a:r>
           </a:p>
           <a:p>
@@ -6668,30 +5847,16 @@
                   <a:srgbClr val="1A1A1A"/>
                 </a:solidFill>
               </a:rPr>
-              <a:t>  python-pptx             Deck generation               Builds directly into organizer's .pptx preserving branding</a:t>
-            </a:r>
-          </a:p>
-          <a:p>
-            <a:pPr algn="l"/>
-            <a:r>
-              <a:rPr sz="1200" b="0">
-                <a:solidFill>
-                  <a:srgbClr val="1A1A1A"/>
-                </a:solidFill>
-              </a:rPr>
               <a:t>  git + GitHub            Version control               Commit history shows iterative, validation-driven development</a:t>
             </a:r>
           </a:p>
           <a:p>
             <a:pPr algn="l"/>
-            <a:r>
-              <a:rPr sz="500" b="0">
-                <a:solidFill>
-                  <a:srgbClr val="1A1A1A"/>
-                </a:solidFill>
-              </a:rPr>
-              <a:t/>
-            </a:r>
+            <a:endParaRPr sz="1200" b="0">
+              <a:solidFill>
+                <a:srgbClr val="1A1A1A"/>
+              </a:solidFill>
+            </a:endParaRPr>
           </a:p>
           <a:p>
             <a:pPr algn="l"/>
@@ -6730,7 +5895,7 @@
       </p:sp>
       <p:pic>
         <p:nvPicPr>
-          <p:cNvPr id="8" name="Picture 7" descr="logos_transparent.png"/>
+          <p:cNvPr id="8" name="Picture 7" descr="logos_clean.png"/>
           <p:cNvPicPr>
             <a:picLocks noChangeAspect="1"/>
           </p:cNvPicPr>
@@ -6744,8 +5909,8 @@
         </p:blipFill>
         <p:spPr>
           <a:xfrm>
-            <a:off x="256032" y="1060704"/>
-            <a:ext cx="1816377" cy="512064"/>
+            <a:off x="256032" y="1049731"/>
+            <a:ext cx="1819656" cy="502920"/>
           </a:xfrm>
           <a:prstGeom prst="rect">
             <a:avLst/>

</xml_diff>

<commit_message>
Fix H2S logo corruption: source from image8.png header, not PDF extraction
image11.png (logos_clean.png) had mirrored/garbled H2S glyphs from the
PDF→alpha-ramp pipeline. Root cause: PDF re-rendering at header scale
distorted the icon-font glyphs.

Fix: extract logo from image8.png (original template author's rendering,
pure black background). Black→transparent via brightness mask is
lossless — no ramp thresholding, no glyph distortion. Applied to slides
2, 6, 7, 9, 10 as image12.png. PDF regenerated.

Co-Authored-By: Claude Sonnet 4.6 <noreply@anthropic.com>
</commit_message>
<xml_diff>
--- a/HackerX_Methodology.pptx
+++ b/HackerX_Methodology.pptx
@@ -2002,22 +2002,22 @@
       </p:sp>
       <p:pic>
         <p:nvPicPr>
-          <p:cNvPr id="6" name="Picture 5" descr="logos_clean.png"/>
+          <p:cNvPr id="6" name="Picture 5" descr="logo_final.png"/>
           <p:cNvPicPr>
             <a:picLocks noChangeAspect="1"/>
           </p:cNvPicPr>
           <p:nvPr/>
         </p:nvPicPr>
         <p:blipFill>
-          <a:blip r:embed="rId3"/>
+          <a:blip r:embed="rId4"/>
           <a:stretch>
             <a:fillRect/>
           </a:stretch>
         </p:blipFill>
         <p:spPr>
           <a:xfrm>
-            <a:off x="256032" y="1049731"/>
-            <a:ext cx="1819656" cy="502920"/>
+            <a:off x="0" y="1056132"/>
+            <a:ext cx="2456863" cy="516870"/>
           </a:xfrm>
           <a:prstGeom prst="rect">
             <a:avLst/>
@@ -2376,22 +2376,22 @@
       </p:sp>
       <p:pic>
         <p:nvPicPr>
-          <p:cNvPr id="6" name="Picture 5" descr="logos_clean.png"/>
+          <p:cNvPr id="6" name="Picture 5" descr="logo_final.png"/>
           <p:cNvPicPr>
             <a:picLocks noChangeAspect="1"/>
           </p:cNvPicPr>
           <p:nvPr/>
         </p:nvPicPr>
         <p:blipFill>
-          <a:blip r:embed="rId3"/>
+          <a:blip r:embed="rId4"/>
           <a:stretch>
             <a:fillRect/>
           </a:stretch>
         </p:blipFill>
         <p:spPr>
           <a:xfrm>
-            <a:off x="256032" y="1049731"/>
-            <a:ext cx="1819656" cy="502920"/>
+            <a:off x="0" y="1056132"/>
+            <a:ext cx="2456863" cy="516870"/>
           </a:xfrm>
           <a:prstGeom prst="rect">
             <a:avLst/>
@@ -4083,22 +4083,22 @@
       </p:sp>
       <p:pic>
         <p:nvPicPr>
-          <p:cNvPr id="21" name="Picture 20" descr="logos_clean.png"/>
+          <p:cNvPr id="21" name="Picture 20" descr="logo_final.png"/>
           <p:cNvPicPr>
             <a:picLocks noChangeAspect="1"/>
           </p:cNvPicPr>
           <p:nvPr/>
         </p:nvPicPr>
         <p:blipFill>
-          <a:blip r:embed="rId3"/>
+          <a:blip r:embed="rId4"/>
           <a:stretch>
             <a:fillRect/>
           </a:stretch>
         </p:blipFill>
         <p:spPr>
           <a:xfrm>
-            <a:off x="256032" y="1049731"/>
-            <a:ext cx="1819656" cy="502920"/>
+            <a:off x="0" y="1056132"/>
+            <a:ext cx="2456863" cy="516870"/>
           </a:xfrm>
           <a:prstGeom prst="rect">
             <a:avLst/>
@@ -5125,22 +5125,22 @@
       </p:sp>
       <p:pic>
         <p:nvPicPr>
-          <p:cNvPr id="28" name="Picture 27" descr="logos_clean.png"/>
+          <p:cNvPr id="28" name="Picture 27" descr="logo_final.png"/>
           <p:cNvPicPr>
             <a:picLocks noChangeAspect="1"/>
           </p:cNvPicPr>
           <p:nvPr/>
         </p:nvPicPr>
         <p:blipFill>
-          <a:blip r:embed="rId4"/>
+          <a:blip r:embed="rId5"/>
           <a:stretch>
             <a:fillRect/>
           </a:stretch>
         </p:blipFill>
         <p:spPr>
           <a:xfrm>
-            <a:off x="256032" y="1049731"/>
-            <a:ext cx="1819656" cy="502920"/>
+            <a:off x="0" y="1056132"/>
+            <a:ext cx="2456863" cy="516870"/>
           </a:xfrm>
           <a:prstGeom prst="rect">
             <a:avLst/>
@@ -5895,22 +5895,22 @@
       </p:sp>
       <p:pic>
         <p:nvPicPr>
-          <p:cNvPr id="8" name="Picture 7" descr="logos_clean.png"/>
+          <p:cNvPr id="8" name="Picture 7" descr="logo_final.png"/>
           <p:cNvPicPr>
             <a:picLocks noChangeAspect="1"/>
           </p:cNvPicPr>
           <p:nvPr/>
         </p:nvPicPr>
         <p:blipFill>
-          <a:blip r:embed="rId4"/>
+          <a:blip r:embed="rId5"/>
           <a:stretch>
             <a:fillRect/>
           </a:stretch>
         </p:blipFill>
         <p:spPr>
           <a:xfrm>
-            <a:off x="256032" y="1049731"/>
-            <a:ext cx="1819656" cy="502920"/>
+            <a:off x="0" y="1056132"/>
+            <a:ext cx="2456863" cy="516870"/>
           </a:xfrm>
           <a:prstGeom prst="rect">
             <a:avLst/>

</xml_diff>

<commit_message>
Step 8 pre-submission fixes: README command, runtime measurement, deck update
- README: reproduce command now matches submission_metadata.yaml exactly
  (was /path/to/candidates.jsonl, now candidates.jsonl)
- submission_metadata.yaml: measured_runtime_seconds updated to 63.6s
  (re-measured 2026-06-30 cold start; previous 116.3s was stale)
- HackerX_Methodology.pptx: PowerPoint-side normalisation from final
  logo fix export pass

Co-Authored-By: Claude Sonnet 4.6 <noreply@anthropic.com>
</commit_message>
<xml_diff>
--- a/HackerX_Methodology.pptx
+++ b/HackerX_Methodology.pptx
@@ -188,7 +188,7 @@
           <a:p>
             <a:fld id="{1D8BD707-D9CF-40AE-B4C6-C98DA3205C09}" type="datetimeFigureOut">
               <a:rPr lang="en-US"/>
-              <a:t>6/29/2026</a:t>
+              <a:t>6/30/2026</a:t>
             </a:fld>
             <a:endParaRPr lang="en-US"/>
           </a:p>
@@ -439,7 +439,7 @@
           <a:p>
             <a:fld id="{1D8BD707-D9CF-40AE-B4C6-C98DA3205C09}" type="datetimeFigureOut">
               <a:rPr lang="en-US"/>
-              <a:t>6/29/2026</a:t>
+              <a:t>6/30/2026</a:t>
             </a:fld>
             <a:endParaRPr lang="en-US"/>
           </a:p>
@@ -653,7 +653,7 @@
           <a:p>
             <a:fld id="{1D8BD707-D9CF-40AE-B4C6-C98DA3205C09}" type="datetimeFigureOut">
               <a:rPr lang="en-US"/>
-              <a:t>6/29/2026</a:t>
+              <a:t>6/30/2026</a:t>
             </a:fld>
             <a:endParaRPr lang="en-US"/>
           </a:p>
@@ -925,7 +925,7 @@
           <a:p>
             <a:fld id="{1D8BD707-D9CF-40AE-B4C6-C98DA3205C09}" type="datetimeFigureOut">
               <a:rPr lang="en-US"/>
-              <a:t>6/29/2026</a:t>
+              <a:t>6/30/2026</a:t>
             </a:fld>
             <a:endParaRPr lang="en-US"/>
           </a:p>
@@ -1044,7 +1044,7 @@
           <a:p>
             <a:fld id="{1D8BD707-D9CF-40AE-B4C6-C98DA3205C09}" type="datetimeFigureOut">
               <a:rPr lang="en-US"/>
-              <a:t>6/29/2026</a:t>
+              <a:t>6/30/2026</a:t>
             </a:fld>
             <a:endParaRPr lang="en-US"/>
           </a:p>
@@ -1285,7 +1285,7 @@
           <a:p>
             <a:fld id="{1D8BD707-D9CF-40AE-B4C6-C98DA3205C09}" type="datetimeFigureOut">
               <a:rPr lang="en-US"/>
-              <a:t>6/29/2026</a:t>
+              <a:t>6/30/2026</a:t>
             </a:fld>
             <a:endParaRPr lang="en-US"/>
           </a:p>
@@ -2009,7 +2009,7 @@
           <p:nvPr/>
         </p:nvPicPr>
         <p:blipFill>
-          <a:blip r:embed="rId4"/>
+          <a:blip r:embed="rId2"/>
           <a:stretch>
             <a:fillRect/>
           </a:stretch>
@@ -2383,7 +2383,7 @@
           <p:nvPr/>
         </p:nvPicPr>
         <p:blipFill>
-          <a:blip r:embed="rId4"/>
+          <a:blip r:embed="rId2"/>
           <a:stretch>
             <a:fillRect/>
           </a:stretch>
@@ -4090,7 +4090,7 @@
           <p:nvPr/>
         </p:nvPicPr>
         <p:blipFill>
-          <a:blip r:embed="rId4"/>
+          <a:blip r:embed="rId2"/>
           <a:stretch>
             <a:fillRect/>
           </a:stretch>
@@ -5132,7 +5132,7 @@
           <p:nvPr/>
         </p:nvPicPr>
         <p:blipFill>
-          <a:blip r:embed="rId5"/>
+          <a:blip r:embed="rId3"/>
           <a:stretch>
             <a:fillRect/>
           </a:stretch>
@@ -5180,7 +5180,7 @@
         </p:nvSpPr>
         <p:spPr>
           <a:xfrm>
-            <a:off x="0" y="1048511"/>
+            <a:off x="0" y="1049731"/>
             <a:ext cx="10055860" cy="533400"/>
           </a:xfrm>
           <a:custGeom>
@@ -5546,22 +5546,28 @@
       </p:sp>
       <p:pic>
         <p:nvPicPr>
-          <p:cNvPr id="7" name="Picture 6" descr="logos_clean.png"/>
+          <p:cNvPr id="4" name="Picture 3" descr="logo_final.png">
+            <a:extLst>
+              <a:ext uri="{FF2B5EF4-FFF2-40B4-BE49-F238E27FC236}">
+                <a16:creationId xmlns:a16="http://schemas.microsoft.com/office/drawing/2014/main" id="{E4385B58-2D76-A4FF-F208-D4E854DFE223}"/>
+              </a:ext>
+            </a:extLst>
+          </p:cNvPr>
           <p:cNvPicPr>
             <a:picLocks noChangeAspect="1"/>
           </p:cNvPicPr>
           <p:nvPr/>
         </p:nvPicPr>
         <p:blipFill>
-          <a:blip r:embed="rId3"/>
+          <a:blip r:embed="rId2"/>
           <a:stretch>
             <a:fillRect/>
           </a:stretch>
         </p:blipFill>
         <p:spPr>
           <a:xfrm>
-            <a:off x="256032" y="1049731"/>
-            <a:ext cx="1819656" cy="502920"/>
+            <a:off x="0" y="1056132"/>
+            <a:ext cx="2456863" cy="516870"/>
           </a:xfrm>
           <a:prstGeom prst="rect">
             <a:avLst/>
@@ -5902,7 +5908,7 @@
           <p:nvPr/>
         </p:nvPicPr>
         <p:blipFill>
-          <a:blip r:embed="rId5"/>
+          <a:blip r:embed="rId3"/>
           <a:stretch>
             <a:fillRect/>
           </a:stretch>

</xml_diff>